<commit_message>
feat: render power-platform-community-conference revision 10 with four voices
- master all variants to -16 LUFS on the latest Remotion adapter
- refresh analysis across all ten revisions and native Office QA

🎙️ - Generated by Copilot

Co-authored-by: Copilot <223556219+Copilot@users.noreply.github.com>
</commit_message>
<xml_diff>
--- a/projects/power-platform-community-conference/release/outputs/deck.pptx
+++ b/projects/power-platform-community-conference/release/outputs/deck.pptx
@@ -880,7 +880,7 @@
         <p:spPr>
           <a:xfrm>
             <a:off x="685800" y="3000000"/>
-            <a:ext cx="9600000" cy="1200000"/>
+            <a:ext cx="9600000" cy="1400000"/>
           </a:xfrm>
           <a:prstGeom prst="rect">
             <a:avLst/>
@@ -1012,7 +1012,7 @@
                   <a:srgbClr val="B0BDBA"/>
                 </a:solidFill>
               </a:rPr>
-              <a:t>power-platform-community-conference-r1</a:t>
+              <a:t>power-platform-community-conference-2026-10-am-michael-kokoro-onnx</a:t>
             </a:r>
           </a:p>
         </p:txBody>
@@ -1288,7 +1288,7 @@
                   <a:srgbClr val="B0BDBA"/>
                 </a:solidFill>
               </a:rPr>
-              <a:t>Sources: [ev-01] Register now for PPCC 2026</a:t>
+              <a:t>Sources: Register now for PPCC 2026: Come for the learning, stay for the community</a:t>
             </a:r>
           </a:p>
         </p:txBody>
@@ -1556,7 +1556,7 @@
                   <a:srgbClr val="B0BDBA"/>
                 </a:solidFill>
               </a:rPr>
-              <a:t>Sources: [ev-01] Register now for PPCC 2026  ·  [ev-04] FAQ | PPCC26  ·  [ev-05] FAQ | PPCC26</a:t>
+              <a:t>Sources: Register now for PPCC 2026: Come for the learning, stay for the community  ·  FAQ | PPCC26</a:t>
             </a:r>
           </a:p>
         </p:txBody>
@@ -1824,7 +1824,7 @@
                   <a:srgbClr val="B0BDBA"/>
                 </a:solidFill>
               </a:rPr>
-              <a:t>Sources: [ev-02] Register now for PPCC 2026  ·  [ev-03] FAQ | PPCC26</a:t>
+              <a:t>Sources: Register now for PPCC 2026: Come for the learning, stay for the community  ·  FAQ | PPCC26</a:t>
             </a:r>
           </a:p>
         </p:txBody>
@@ -2087,7 +2087,7 @@
                   <a:srgbClr val="B0BDBA"/>
                 </a:solidFill>
               </a:rPr>
-              <a:t>[ev-03] FAQ | PPCC26</a:t>
+              <a:t>FAQ | PPCC26</a:t>
             </a:r>
           </a:p>
         </p:txBody>
@@ -2131,7 +2131,7 @@
                   <a:srgbClr val="B0BDBA"/>
                 </a:solidFill>
               </a:rPr>
-              <a:t>Sources: [ev-03] FAQ | PPCC26</a:t>
+              <a:t>Sources: FAQ | PPCC26</a:t>
             </a:r>
           </a:p>
         </p:txBody>
@@ -2307,7 +2307,7 @@
               </a:spcAft>
             </a:pPr>
             <a:r>
-              <a:rPr lang="en-US" sz="1800" b="1">
+              <a:rPr lang="en-US" sz="1400" b="1">
                 <a:solidFill>
                   <a:srgbClr val="F2FBF8"/>
                 </a:solidFill>
@@ -2315,7 +2315,7 @@
               <a:t>Register now for PPCC 2026: Come for the learning, stay for the community</a:t>
             </a:r>
             <a:r>
-              <a:rPr lang="en-US" sz="1200">
+              <a:rPr lang="en-US" sz="1100">
                 <a:solidFill>
                   <a:srgbClr val="B0BDBA"/>
                 </a:solidFill>
@@ -2329,11 +2329,11 @@
                 <a:spcPct val="105000"/>
               </a:lnSpc>
               <a:spcAft>
-                <a:spcPts val="1400"/>
+                <a:spcPts val="900"/>
               </a:spcAft>
             </a:pPr>
             <a:r>
-              <a:rPr lang="en-US" sz="1400">
+              <a:rPr lang="en-US" sz="1100">
                 <a:solidFill>
                   <a:srgbClr val="18A999"/>
                 </a:solidFill>
@@ -2351,7 +2351,7 @@
               </a:spcAft>
             </a:pPr>
             <a:r>
-              <a:rPr lang="en-US" sz="1800" b="1">
+              <a:rPr lang="en-US" sz="1400" b="1">
                 <a:solidFill>
                   <a:srgbClr val="F2FBF8"/>
                 </a:solidFill>
@@ -2359,7 +2359,7 @@
               <a:t>FAQ | PPCC26</a:t>
             </a:r>
             <a:r>
-              <a:rPr lang="en-US" sz="1200">
+              <a:rPr lang="en-US" sz="1100">
                 <a:solidFill>
                   <a:srgbClr val="B0BDBA"/>
                 </a:solidFill>
@@ -2373,11 +2373,11 @@
                 <a:spcPct val="105000"/>
               </a:lnSpc>
               <a:spcAft>
-                <a:spcPts val="1400"/>
+                <a:spcPts val="900"/>
               </a:spcAft>
             </a:pPr>
             <a:r>
-              <a:rPr lang="en-US" sz="1400">
+              <a:rPr lang="en-US" sz="1100">
                 <a:solidFill>
                   <a:srgbClr val="18A999"/>
                 </a:solidFill>
@@ -2426,7 +2426,7 @@
                   <a:srgbClr val="B0BDBA"/>
                 </a:solidFill>
               </a:rPr>
-              <a:t>power-platform-community-conference-r1</a:t>
+              <a:t>power-platform-community-conference-2026-10-am-michael-kokoro-onnx</a:t>
             </a:r>
           </a:p>
         </p:txBody>

</xml_diff>

<commit_message>
feat: regenerate power-platform-community-conference with LF-stable release generation
- render four voices so release-verify passes on any checkout

🎙️ - Generated by Copilot

Co-authored-by: Copilot <223556219+Copilot@users.noreply.github.com>
</commit_message>
<xml_diff>
--- a/projects/power-platform-community-conference/release/outputs/deck.pptx
+++ b/projects/power-platform-community-conference/release/outputs/deck.pptx
@@ -1012,7 +1012,7 @@
                   <a:srgbClr val="B0BDBA"/>
                 </a:solidFill>
               </a:rPr>
-              <a:t>power-platform-community-conference-2026-10-am-michael-kokoro-onnx</a:t>
+              <a:t>power-platform-community-conference-2026-11-am-michael-kokoro-onnx</a:t>
             </a:r>
           </a:p>
         </p:txBody>
@@ -2426,7 +2426,7 @@
                   <a:srgbClr val="B0BDBA"/>
                 </a:solidFill>
               </a:rPr>
-              <a:t>power-platform-community-conference-2026-10-am-michael-kokoro-onnx</a:t>
+              <a:t>power-platform-community-conference-2026-11-am-michael-kokoro-onnx</a:t>
             </a:r>
           </a:p>
         </p:txBody>

</xml_diff>

<commit_message>
feat: regenerate power-platform-community-conference with its brand theme
- render four voices with the brand header band, palette and fonts

🎨 - Generated by Copilot

Co-authored-by: Copilot <223556219+Copilot@users.noreply.github.com>
</commit_message>
<xml_diff>
--- a/projects/power-platform-community-conference/release/outputs/deck.pptx
+++ b/projects/power-platform-community-conference/release/outputs/deck.pptx
@@ -18,6 +18,16 @@
     <a:defPPr>
       <a:defRPr lang="en-US"/>
     </a:defPPr>
+    <a:lvl1pPr algn="l" defTabSz="914400" marL="0" indent="0">
+      <a:defRPr sz="1800" kern="1200">
+        <a:solidFill>
+          <a:schemeClr val="tx1"/>
+        </a:solidFill>
+        <a:latin typeface="+mn-lt"/>
+        <a:ea typeface="+mn-ea"/>
+        <a:cs typeface="+mn-cs"/>
+      </a:defRPr>
+    </a:lvl1pPr>
   </p:defaultTextStyle>
 </p:presentation>
 </file>
@@ -81,11 +91,11 @@
                   <a:srgbClr val="111111"/>
                 </a:solidFill>
               </a:rPr>
-              <a:t>Bottom line: recommend sending a focused cross-functional team to PPCC 2026 with one objective: return with a governed AI, app, and automation pilot proposal.
-This is a recommendation, not a measured outcome. Treat the event as a structured learning sprint for business, platform, data, and risk leaders.
-PPCC runs October 27 through 29 at the MGM Grand in Las Vegas. Applied workshops run before and after the main conference.
-Microsoft frames PPCC around Copilot, agents, apps, automation, and data. The program connects those capabilities to trusted data, implementation, architecture, and governance. That is the bridge from innovation ambition to execution controls.
-After the event, require one pilot charter naming the workflow, owner, trusted data, guardrails, and a testable success measure. Expand only when that evidence supports the next decision.
+              <a:t>PPCC 2026 is an upcoming opportunity to connect agents, apps, automation, trusted data, and governance to a concrete executive pilot decision.
+Recommendation: send a focused business, platform, data, and risk team with one mandate: return with a governed AI, app, and automation pilot charter.
+Main conference: October 27-29 at the MGM Grand in Las Vegas. Workshops: October 25-26 and October 30.
+PPCC connects agents, apps, automation, and trusted data with implementation, architecture, governance, and AI-driven scenarios.
+Ask the team to return with the workflow, owner, trusted data, guardrails, and testable success measure for one pilot. Expansion should depend on that evidence, not conference enthusiasm.
 Evidence: PPCC 2026 runs October 27-29 at the MGM Grand in Las Vegas. [ev-01] Register now for PPCC 2026: Come for the learning, stay for the community
 Evidence: Microsoft frames PPCC around Copilot, agents, apps, automation, and data. [ev-01] Register now for PPCC 2026: Come for the learning, stay for the community
 Evidence: PPCC covers agents, apps, automation, and trusted data as governed business solutions. [ev-02] Register now for PPCC 2026: Come for the learning, stay for the community
@@ -785,7 +795,7 @@
     <p:bg>
       <p:bgPr>
         <a:solidFill>
-          <a:srgbClr val="071F1B"/>
+          <a:srgbClr val="F5F9F8"/>
         </a:solidFill>
         <a:effectLst/>
       </p:bgPr>
@@ -799,20 +809,20 @@
       <p:grpSpPr/>
       <p:sp>
         <p:nvSpPr>
-          <p:cNvPr id="2" name="Accent band"/>
+          <p:cNvPr id="2" name="Brand band"/>
           <p:cNvSpPr/>
           <p:nvPr/>
         </p:nvSpPr>
         <p:spPr>
           <a:xfrm>
             <a:off x="0" y="0"/>
-            <a:ext cx="12192000" cy="91440"/>
+            <a:ext cx="12192000" cy="502920"/>
           </a:xfrm>
           <a:prstGeom prst="rect">
             <a:avLst/>
           </a:prstGeom>
           <a:solidFill>
-            <a:srgbClr val="18A999"/>
+            <a:srgbClr val="0A172A"/>
           </a:solidFill>
           <a:ln>
             <a:noFill/>
@@ -821,14 +831,36 @@
       </p:sp>
       <p:sp>
         <p:nvSpPr>
-          <p:cNvPr id="3" name="Title"/>
-          <p:cNvSpPr txBox="1"/>
-          <p:nvPr/>
-        </p:nvSpPr>
-        <p:spPr>
-          <a:xfrm>
-            <a:off x="685800" y="900000"/>
-            <a:ext cx="10820400" cy="2000000"/>
+          <p:cNvPr id="3" name="Highlight rule"/>
+          <p:cNvSpPr/>
+          <p:nvPr/>
+        </p:nvSpPr>
+        <p:spPr>
+          <a:xfrm>
+            <a:off x="0" y="502920"/>
+            <a:ext cx="12192000" cy="45720"/>
+          </a:xfrm>
+          <a:prstGeom prst="rect">
+            <a:avLst/>
+          </a:prstGeom>
+          <a:solidFill>
+            <a:srgbClr val="2FFFE0"/>
+          </a:solidFill>
+          <a:ln>
+            <a:noFill/>
+          </a:ln>
+        </p:spPr>
+      </p:sp>
+      <p:sp>
+        <p:nvSpPr>
+          <p:cNvPr id="4" name="Deck kicker"/>
+          <p:cNvSpPr txBox="1"/>
+          <p:nvPr/>
+        </p:nvSpPr>
+        <p:spPr>
+          <a:xfrm>
+            <a:off x="685800" y="0"/>
+            <a:ext cx="8400000" cy="502920"/>
           </a:xfrm>
           <a:prstGeom prst="rect">
             <a:avLst/>
@@ -853,45 +885,74 @@
               </a:spcAft>
             </a:pPr>
             <a:r>
-              <a:rPr lang="en-US" sz="3600" b="1">
-                <a:solidFill>
-                  <a:srgbClr val="F2FBF8"/>
-                </a:solidFill>
-              </a:rPr>
-              <a:t>PPCC 2026:</a:t>
-            </a:r>
-            <a:r>
-              <a:rPr lang="en-US" sz="3600" b="1">
-                <a:solidFill>
-                  <a:srgbClr val="18A999"/>
-                </a:solidFill>
-              </a:rPr>
-              <a:t> turn conference learning into one governed pilot</a:t>
-            </a:r>
-          </a:p>
-        </p:txBody>
-      </p:sp>
-      <p:sp>
-        <p:nvSpPr>
-          <p:cNvPr id="4" name="Summary"/>
-          <p:cNvSpPr txBox="1"/>
-          <p:nvPr/>
-        </p:nvSpPr>
-        <p:spPr>
-          <a:xfrm>
-            <a:off x="685800" y="3000000"/>
-            <a:ext cx="9600000" cy="1400000"/>
-          </a:xfrm>
-          <a:prstGeom prst="rect">
-            <a:avLst/>
-          </a:prstGeom>
-          <a:noFill/>
-          <a:ln>
-            <a:noFill/>
-          </a:ln>
-        </p:spPr>
-        <p:txBody>
-          <a:bodyPr wrap="square" lIns="182880" tIns="91440" rIns="182880" bIns="91440" anchor="t">
+              <a:rPr lang="en-US" sz="1100" b="1" cap="all" spc="120">
+                <a:solidFill>
+                  <a:srgbClr val="FFFFFF"/>
+                </a:solidFill>
+              </a:rPr>
+              <a:t>PPCC 2026</a:t>
+            </a:r>
+          </a:p>
+        </p:txBody>
+      </p:sp>
+      <p:sp>
+        <p:nvSpPr>
+          <p:cNvPr id="5" name="Slide number"/>
+          <p:cNvSpPr txBox="1"/>
+          <p:nvPr/>
+        </p:nvSpPr>
+        <p:spPr>
+          <a:xfrm>
+            <a:off x="9100000" y="0"/>
+            <a:ext cx="2406400" cy="502920"/>
+          </a:xfrm>
+          <a:prstGeom prst="rect">
+            <a:avLst/>
+          </a:prstGeom>
+          <a:noFill/>
+          <a:ln>
+            <a:noFill/>
+          </a:ln>
+        </p:spPr>
+        <p:txBody>
+          <a:bodyPr wrap="square" lIns="182880" tIns="91440" rIns="182880" bIns="91440" anchor="ctr">
+            <a:normAutofit/>
+          </a:bodyPr>
+          <a:lstStyle/>
+          <a:p>
+            <a:pPr algn="r"/>
+            <a:r>
+              <a:rPr lang="en-US" sz="1100" b="1" cap="all" spc="120">
+                <a:solidFill>
+                  <a:srgbClr val="BABEC3"/>
+                </a:solidFill>
+              </a:rPr>
+              <a:t>1 / 6</a:t>
+            </a:r>
+          </a:p>
+        </p:txBody>
+      </p:sp>
+      <p:sp>
+        <p:nvSpPr>
+          <p:cNvPr id="6" name="Title"/>
+          <p:cNvSpPr txBox="1"/>
+          <p:nvPr/>
+        </p:nvSpPr>
+        <p:spPr>
+          <a:xfrm>
+            <a:off x="685800" y="1100000"/>
+            <a:ext cx="10820400" cy="2000000"/>
+          </a:xfrm>
+          <a:prstGeom prst="rect">
+            <a:avLst/>
+          </a:prstGeom>
+          <a:noFill/>
+          <a:ln>
+            <a:noFill/>
+          </a:ln>
+        </p:spPr>
+        <p:txBody>
+          <a:bodyPr wrap="square" lIns="182880" tIns="91440" rIns="182880" bIns="91440" anchor="ctr">
             <a:normAutofit/>
           </a:bodyPr>
           <a:lstStyle/>
@@ -905,43 +966,47 @@
               </a:spcAft>
             </a:pPr>
             <a:r>
-              <a:rPr lang="en-US" sz="1800">
-                <a:solidFill>
-                  <a:srgbClr val="B0BDBA"/>
-                </a:solidFill>
-              </a:rPr>
-              <a:t>PPCC 2026 is an upcoming opportunity to connect agents, apps, automation, trusted data, and governance to a concrete executive pilot decision.</a:t>
-            </a:r>
-          </a:p>
-        </p:txBody>
-      </p:sp>
-      <p:sp>
-        <p:nvSpPr>
-          <p:cNvPr id="5" name="Decision"/>
-          <p:cNvSpPr/>
-          <p:nvPr/>
-        </p:nvSpPr>
-        <p:spPr>
-          <a:xfrm>
-            <a:off x="685800" y="4500000"/>
-            <a:ext cx="10820400" cy="1000000"/>
-          </a:xfrm>
-          <a:prstGeom prst="roundRect">
-            <a:avLst>
-              <a:gd name="adj" fmla="val 9000"/>
-            </a:avLst>
-          </a:prstGeom>
-          <a:solidFill>
-            <a:srgbClr val="0A352F"/>
-          </a:solidFill>
-          <a:ln w="12700">
-            <a:solidFill>
-              <a:srgbClr val="18A999"/>
-            </a:solidFill>
-          </a:ln>
-        </p:spPr>
-        <p:txBody>
-          <a:bodyPr wrap="square" lIns="182880" tIns="91440" rIns="182880" bIns="91440" anchor="ctr">
+              <a:rPr lang="en-US" sz="3600" b="1">
+                <a:solidFill>
+                  <a:srgbClr val="081222"/>
+                </a:solidFill>
+                <a:latin typeface="+mj-lt"/>
+              </a:rPr>
+              <a:t>PPCC 2026:</a:t>
+            </a:r>
+            <a:r>
+              <a:rPr lang="en-US" sz="3600" b="1">
+                <a:solidFill>
+                  <a:srgbClr val="17796A"/>
+                </a:solidFill>
+                <a:latin typeface="+mj-lt"/>
+              </a:rPr>
+              <a:t> turn conference learning into one governed pilot</a:t>
+            </a:r>
+          </a:p>
+        </p:txBody>
+      </p:sp>
+      <p:sp>
+        <p:nvSpPr>
+          <p:cNvPr id="7" name="Summary"/>
+          <p:cNvSpPr txBox="1"/>
+          <p:nvPr/>
+        </p:nvSpPr>
+        <p:spPr>
+          <a:xfrm>
+            <a:off x="685800" y="3150000"/>
+            <a:ext cx="9600000" cy="1400000"/>
+          </a:xfrm>
+          <a:prstGeom prst="rect">
+            <a:avLst/>
+          </a:prstGeom>
+          <a:noFill/>
+          <a:ln>
+            <a:noFill/>
+          </a:ln>
+        </p:spPr>
+        <p:txBody>
+          <a:bodyPr wrap="square" lIns="182880" tIns="91440" rIns="182880" bIns="91440" anchor="t">
             <a:normAutofit/>
           </a:bodyPr>
           <a:lstStyle/>
@@ -955,45 +1020,43 @@
               </a:spcAft>
             </a:pPr>
             <a:r>
-              <a:rPr lang="en-US" sz="1400" b="1">
-                <a:solidFill>
-                  <a:srgbClr val="18A999"/>
-                </a:solidFill>
-              </a:rPr>
-              <a:t>DECISION  </a:t>
-            </a:r>
-            <a:r>
-              <a:rPr lang="en-US" sz="1600" b="1">
-                <a:solidFill>
-                  <a:srgbClr val="F2FBF8"/>
-                </a:solidFill>
-              </a:rPr>
-              <a:t>Recommendation: send a focused team to PPCC 2026 to return with one governed AI, app, and automation pilot charter.</a:t>
-            </a:r>
-          </a:p>
-        </p:txBody>
-      </p:sp>
-      <p:sp>
-        <p:nvSpPr>
-          <p:cNvPr id="6" name="Footer"/>
-          <p:cNvSpPr txBox="1"/>
-          <p:nvPr/>
-        </p:nvSpPr>
-        <p:spPr>
-          <a:xfrm>
-            <a:off x="685800" y="6250000"/>
-            <a:ext cx="9400000" cy="420000"/>
-          </a:xfrm>
-          <a:prstGeom prst="rect">
-            <a:avLst/>
-          </a:prstGeom>
-          <a:noFill/>
-          <a:ln>
-            <a:noFill/>
-          </a:ln>
-        </p:spPr>
-        <p:txBody>
-          <a:bodyPr wrap="square" lIns="182880" tIns="91440" rIns="182880" bIns="91440" anchor="t">
+              <a:rPr lang="en-US" sz="1800">
+                <a:solidFill>
+                  <a:srgbClr val="6B717A"/>
+                </a:solidFill>
+              </a:rPr>
+              <a:t>PPCC 2026 is an upcoming opportunity to connect agents, apps, automation, trusted data, and governance to a concrete executive pilot decision.</a:t>
+            </a:r>
+          </a:p>
+        </p:txBody>
+      </p:sp>
+      <p:sp>
+        <p:nvSpPr>
+          <p:cNvPr id="8" name="Decision"/>
+          <p:cNvSpPr/>
+          <p:nvPr/>
+        </p:nvSpPr>
+        <p:spPr>
+          <a:xfrm>
+            <a:off x="685800" y="4650000"/>
+            <a:ext cx="10820400" cy="1000000"/>
+          </a:xfrm>
+          <a:prstGeom prst="roundRect">
+            <a:avLst>
+              <a:gd name="adj" fmla="val 6000"/>
+            </a:avLst>
+          </a:prstGeom>
+          <a:solidFill>
+            <a:srgbClr val="E0FFFA"/>
+          </a:solidFill>
+          <a:ln w="12700">
+            <a:solidFill>
+              <a:srgbClr val="1D9E8B"/>
+            </a:solidFill>
+          </a:ln>
+        </p:spPr>
+        <p:txBody>
+          <a:bodyPr wrap="square" lIns="182880" tIns="91440" rIns="182880" bIns="91440" anchor="ctr">
             <a:normAutofit/>
           </a:bodyPr>
           <a:lstStyle/>
@@ -1007,49 +1070,64 @@
               </a:spcAft>
             </a:pPr>
             <a:r>
+              <a:rPr lang="en-US" sz="1400" b="1">
+                <a:solidFill>
+                  <a:srgbClr val="17796A"/>
+                </a:solidFill>
+              </a:rPr>
+              <a:t>DECISION  </a:t>
+            </a:r>
+            <a:r>
+              <a:rPr lang="en-US" sz="1600" b="1">
+                <a:solidFill>
+                  <a:srgbClr val="081222"/>
+                </a:solidFill>
+              </a:rPr>
+              <a:t>Recommendation: send a focused team to PPCC 2026 to return with one governed AI, app, and automation pilot charter.</a:t>
+            </a:r>
+          </a:p>
+        </p:txBody>
+      </p:sp>
+      <p:sp>
+        <p:nvSpPr>
+          <p:cNvPr id="9" name="Footer"/>
+          <p:cNvSpPr txBox="1"/>
+          <p:nvPr/>
+        </p:nvSpPr>
+        <p:spPr>
+          <a:xfrm>
+            <a:off x="685800" y="6250000"/>
+            <a:ext cx="10820400" cy="420000"/>
+          </a:xfrm>
+          <a:prstGeom prst="rect">
+            <a:avLst/>
+          </a:prstGeom>
+          <a:noFill/>
+          <a:ln>
+            <a:noFill/>
+          </a:ln>
+        </p:spPr>
+        <p:txBody>
+          <a:bodyPr wrap="square" lIns="182880" tIns="91440" rIns="182880" bIns="91440" anchor="t">
+            <a:normAutofit/>
+          </a:bodyPr>
+          <a:lstStyle/>
+          <a:p>
+            <a:pPr algn="l">
+              <a:lnSpc>
+                <a:spcPct val="105000"/>
+              </a:lnSpc>
+              <a:spcAft>
+                <a:spcPts val="0"/>
+              </a:spcAft>
+            </a:pPr>
+            <a:r>
               <a:rPr lang="en-US" sz="1000">
                 <a:solidFill>
-                  <a:srgbClr val="B0BDBA"/>
-                </a:solidFill>
-              </a:rPr>
-              <a:t>power-platform-community-conference-2026-11-am-michael-kokoro-onnx</a:t>
-            </a:r>
-          </a:p>
-        </p:txBody>
-      </p:sp>
-      <p:sp>
-        <p:nvSpPr>
-          <p:cNvPr id="7" name="Slide number"/>
-          <p:cNvSpPr txBox="1"/>
-          <p:nvPr/>
-        </p:nvSpPr>
-        <p:spPr>
-          <a:xfrm>
-            <a:off x="10100000" y="6250000"/>
-            <a:ext cx="1400000" cy="420000"/>
-          </a:xfrm>
-          <a:prstGeom prst="rect">
-            <a:avLst/>
-          </a:prstGeom>
-          <a:noFill/>
-          <a:ln>
-            <a:noFill/>
-          </a:ln>
-        </p:spPr>
-        <p:txBody>
-          <a:bodyPr wrap="square" lIns="182880" tIns="91440" rIns="182880" bIns="91440" anchor="t">
-            <a:normAutofit/>
-          </a:bodyPr>
-          <a:lstStyle/>
-          <a:p>
-            <a:pPr algn="r"/>
-            <a:r>
-              <a:rPr lang="en-US" sz="1000">
-                <a:solidFill>
-                  <a:srgbClr val="B0BDBA"/>
-                </a:solidFill>
-              </a:rPr>
-              <a:t>1 / 6</a:t>
+                  <a:srgbClr val="6B717A"/>
+                </a:solidFill>
+              </a:rPr>
+              <a:t>power-platform-community-conference-2026-12-am-michael-kokoro-onnx</a:t>
             </a:r>
           </a:p>
         </p:txBody>
@@ -1068,7 +1146,7 @@
     <p:bg>
       <p:bgPr>
         <a:solidFill>
-          <a:srgbClr val="071F1B"/>
+          <a:srgbClr val="F5F9F8"/>
         </a:solidFill>
         <a:effectLst/>
       </p:bgPr>
@@ -1082,20 +1160,20 @@
       <p:grpSpPr/>
       <p:sp>
         <p:nvSpPr>
-          <p:cNvPr id="2" name="Accent band"/>
+          <p:cNvPr id="2" name="Brand band"/>
           <p:cNvSpPr/>
           <p:nvPr/>
         </p:nvSpPr>
         <p:spPr>
           <a:xfrm>
             <a:off x="0" y="0"/>
-            <a:ext cx="12192000" cy="91440"/>
+            <a:ext cx="12192000" cy="502920"/>
           </a:xfrm>
           <a:prstGeom prst="rect">
             <a:avLst/>
           </a:prstGeom>
           <a:solidFill>
-            <a:srgbClr val="18A999"/>
+            <a:srgbClr val="0A172A"/>
           </a:solidFill>
           <a:ln>
             <a:noFill/>
@@ -1104,14 +1182,36 @@
       </p:sp>
       <p:sp>
         <p:nvSpPr>
-          <p:cNvPr id="3" name="Title"/>
-          <p:cNvSpPr txBox="1"/>
-          <p:nvPr/>
-        </p:nvSpPr>
-        <p:spPr>
-          <a:xfrm>
-            <a:off x="685800" y="420000"/>
-            <a:ext cx="10820400" cy="1150000"/>
+          <p:cNvPr id="3" name="Highlight rule"/>
+          <p:cNvSpPr/>
+          <p:nvPr/>
+        </p:nvSpPr>
+        <p:spPr>
+          <a:xfrm>
+            <a:off x="0" y="502920"/>
+            <a:ext cx="12192000" cy="45720"/>
+          </a:xfrm>
+          <a:prstGeom prst="rect">
+            <a:avLst/>
+          </a:prstGeom>
+          <a:solidFill>
+            <a:srgbClr val="2FFFE0"/>
+          </a:solidFill>
+          <a:ln>
+            <a:noFill/>
+          </a:ln>
+        </p:spPr>
+      </p:sp>
+      <p:sp>
+        <p:nvSpPr>
+          <p:cNvPr id="4" name="Deck kicker"/>
+          <p:cNvSpPr txBox="1"/>
+          <p:nvPr/>
+        </p:nvSpPr>
+        <p:spPr>
+          <a:xfrm>
+            <a:off x="685800" y="0"/>
+            <a:ext cx="8400000" cy="502920"/>
           </a:xfrm>
           <a:prstGeom prst="rect">
             <a:avLst/>
@@ -1136,45 +1236,74 @@
               </a:spcAft>
             </a:pPr>
             <a:r>
-              <a:rPr lang="en-US" sz="2600" b="1">
-                <a:solidFill>
-                  <a:srgbClr val="F2FBF8"/>
-                </a:solidFill>
-              </a:rPr>
-              <a:t>Bottom line:</a:t>
-            </a:r>
-            <a:r>
-              <a:rPr lang="en-US" sz="2600" b="1">
-                <a:solidFill>
-                  <a:srgbClr val="18A999"/>
-                </a:solidFill>
-              </a:rPr>
-              <a:t> send a focused team with one pilot objective</a:t>
-            </a:r>
-          </a:p>
-        </p:txBody>
-      </p:sp>
-      <p:sp>
-        <p:nvSpPr>
-          <p:cNvPr id="4" name="Body"/>
-          <p:cNvSpPr txBox="1"/>
-          <p:nvPr/>
-        </p:nvSpPr>
-        <p:spPr>
-          <a:xfrm>
-            <a:off x="685800" y="1750000"/>
-            <a:ext cx="3900000" cy="3900000"/>
-          </a:xfrm>
-          <a:prstGeom prst="rect">
-            <a:avLst/>
-          </a:prstGeom>
-          <a:noFill/>
-          <a:ln>
-            <a:noFill/>
-          </a:ln>
-        </p:spPr>
-        <p:txBody>
-          <a:bodyPr wrap="square" lIns="182880" tIns="91440" rIns="182880" bIns="91440" anchor="t">
+              <a:rPr lang="en-US" sz="1100" b="1" cap="all" spc="120">
+                <a:solidFill>
+                  <a:srgbClr val="FFFFFF"/>
+                </a:solidFill>
+              </a:rPr>
+              <a:t>PPCC 2026</a:t>
+            </a:r>
+          </a:p>
+        </p:txBody>
+      </p:sp>
+      <p:sp>
+        <p:nvSpPr>
+          <p:cNvPr id="5" name="Slide number"/>
+          <p:cNvSpPr txBox="1"/>
+          <p:nvPr/>
+        </p:nvSpPr>
+        <p:spPr>
+          <a:xfrm>
+            <a:off x="9100000" y="0"/>
+            <a:ext cx="2406400" cy="502920"/>
+          </a:xfrm>
+          <a:prstGeom prst="rect">
+            <a:avLst/>
+          </a:prstGeom>
+          <a:noFill/>
+          <a:ln>
+            <a:noFill/>
+          </a:ln>
+        </p:spPr>
+        <p:txBody>
+          <a:bodyPr wrap="square" lIns="182880" tIns="91440" rIns="182880" bIns="91440" anchor="ctr">
+            <a:normAutofit/>
+          </a:bodyPr>
+          <a:lstStyle/>
+          <a:p>
+            <a:pPr algn="r"/>
+            <a:r>
+              <a:rPr lang="en-US" sz="1100" b="1" cap="all" spc="120">
+                <a:solidFill>
+                  <a:srgbClr val="BABEC3"/>
+                </a:solidFill>
+              </a:rPr>
+              <a:t>2 / 6</a:t>
+            </a:r>
+          </a:p>
+        </p:txBody>
+      </p:sp>
+      <p:sp>
+        <p:nvSpPr>
+          <p:cNvPr id="6" name="Title"/>
+          <p:cNvSpPr txBox="1"/>
+          <p:nvPr/>
+        </p:nvSpPr>
+        <p:spPr>
+          <a:xfrm>
+            <a:off x="685800" y="700000"/>
+            <a:ext cx="10820400" cy="1150000"/>
+          </a:xfrm>
+          <a:prstGeom prst="rect">
+            <a:avLst/>
+          </a:prstGeom>
+          <a:noFill/>
+          <a:ln>
+            <a:noFill/>
+          </a:ln>
+        </p:spPr>
+        <p:txBody>
+          <a:bodyPr wrap="square" lIns="182880" tIns="91440" rIns="182880" bIns="91440" anchor="ctr">
             <a:normAutofit/>
           </a:bodyPr>
           <a:lstStyle/>
@@ -1188,77 +1317,36 @@
               </a:spcAft>
             </a:pPr>
             <a:r>
-              <a:rPr lang="en-US" sz="2500">
-                <a:solidFill>
-                  <a:srgbClr val="F2FBF8"/>
-                </a:solidFill>
-              </a:rPr>
-              <a:t>Recommendation: send a focused business, platform, data, and risk team with one mandate: return with a governed AI, app, and automation pilot charter.</a:t>
-            </a:r>
-          </a:p>
-        </p:txBody>
-      </p:sp>
-      <p:sp>
-        <p:nvSpPr>
-          <p:cNvPr id="5" name="Accent rule"/>
-          <p:cNvSpPr/>
-          <p:nvPr/>
-        </p:nvSpPr>
-        <p:spPr>
-          <a:xfrm>
-            <a:off x="548640" y="1800000"/>
-            <a:ext cx="45720" cy="3800000"/>
-          </a:xfrm>
-          <a:prstGeom prst="rect">
-            <a:avLst/>
-          </a:prstGeom>
-          <a:solidFill>
-            <a:srgbClr val="18A999"/>
-          </a:solidFill>
-          <a:ln>
-            <a:noFill/>
-          </a:ln>
-        </p:spPr>
-      </p:sp>
-      <p:pic>
-        <p:nvPicPr>
-          <p:cNvPr id="6" name="Asset executive-pilot-team" descr="Three-step executive flow from a focused team to one chosen opportunity and one governed pilot."/>
-          <p:cNvPicPr>
-            <a:picLocks noChangeAspect="1"/>
-          </p:cNvPicPr>
-          <p:nvPr/>
-        </p:nvPicPr>
-        <p:blipFill>
-          <a:blip r:embed="rIdImage1"/>
-          <a:stretch>
-            <a:fillRect/>
-          </a:stretch>
-        </p:blipFill>
-        <p:spPr>
-          <a:xfrm>
-            <a:off x="5000000" y="2021875"/>
-            <a:ext cx="6500000" cy="3656250"/>
-          </a:xfrm>
-          <a:prstGeom prst="rect">
-            <a:avLst/>
-          </a:prstGeom>
-          <a:ln>
-            <a:solidFill>
-              <a:srgbClr val="D9D9D9"/>
-            </a:solidFill>
-          </a:ln>
-        </p:spPr>
-      </p:pic>
-      <p:sp>
-        <p:nvSpPr>
-          <p:cNvPr id="7" name="Footer"/>
-          <p:cNvSpPr txBox="1"/>
-          <p:nvPr/>
-        </p:nvSpPr>
-        <p:spPr>
-          <a:xfrm>
-            <a:off x="685800" y="6250000"/>
-            <a:ext cx="9400000" cy="420000"/>
+              <a:rPr lang="en-US" sz="2600" b="1">
+                <a:solidFill>
+                  <a:srgbClr val="081222"/>
+                </a:solidFill>
+                <a:latin typeface="+mj-lt"/>
+              </a:rPr>
+              <a:t>Bottom line:</a:t>
+            </a:r>
+            <a:r>
+              <a:rPr lang="en-US" sz="2600" b="1">
+                <a:solidFill>
+                  <a:srgbClr val="17796A"/>
+                </a:solidFill>
+                <a:latin typeface="+mj-lt"/>
+              </a:rPr>
+              <a:t> send a focused team with one pilot objective</a:t>
+            </a:r>
+          </a:p>
+        </p:txBody>
+      </p:sp>
+      <p:sp>
+        <p:nvSpPr>
+          <p:cNvPr id="7" name="Body"/>
+          <p:cNvSpPr txBox="1"/>
+          <p:nvPr/>
+        </p:nvSpPr>
+        <p:spPr>
+          <a:xfrm>
+            <a:off x="685800" y="1950000"/>
+            <a:ext cx="3900000" cy="3900000"/>
           </a:xfrm>
           <a:prstGeom prst="rect">
             <a:avLst/>
@@ -1283,49 +1371,107 @@
               </a:spcAft>
             </a:pPr>
             <a:r>
+              <a:rPr lang="en-US" sz="2500">
+                <a:solidFill>
+                  <a:srgbClr val="081222"/>
+                </a:solidFill>
+              </a:rPr>
+              <a:t>Recommendation: send a focused business, platform, data, and risk team with one mandate: return with a governed AI, app, and automation pilot charter.</a:t>
+            </a:r>
+          </a:p>
+        </p:txBody>
+      </p:sp>
+      <p:sp>
+        <p:nvSpPr>
+          <p:cNvPr id="8" name="Accent rule"/>
+          <p:cNvSpPr/>
+          <p:nvPr/>
+        </p:nvSpPr>
+        <p:spPr>
+          <a:xfrm>
+            <a:off x="548640" y="2000000"/>
+            <a:ext cx="45720" cy="3800000"/>
+          </a:xfrm>
+          <a:prstGeom prst="rect">
+            <a:avLst/>
+          </a:prstGeom>
+          <a:solidFill>
+            <a:srgbClr val="17796A"/>
+          </a:solidFill>
+          <a:ln>
+            <a:noFill/>
+          </a:ln>
+        </p:spPr>
+      </p:sp>
+      <p:pic>
+        <p:nvPicPr>
+          <p:cNvPr id="9" name="Asset executive-pilot-team" descr="Three-step executive flow from a focused team to one chosen opportunity and one governed pilot."/>
+          <p:cNvPicPr>
+            <a:picLocks noChangeAspect="1"/>
+          </p:cNvPicPr>
+          <p:nvPr/>
+        </p:nvPicPr>
+        <p:blipFill>
+          <a:blip r:embed="rIdImage1"/>
+          <a:stretch>
+            <a:fillRect/>
+          </a:stretch>
+        </p:blipFill>
+        <p:spPr>
+          <a:xfrm>
+            <a:off x="5000000" y="2221875"/>
+            <a:ext cx="6500000" cy="3656250"/>
+          </a:xfrm>
+          <a:prstGeom prst="rect">
+            <a:avLst/>
+          </a:prstGeom>
+          <a:ln>
+            <a:solidFill>
+              <a:srgbClr val="D9D9D9"/>
+            </a:solidFill>
+          </a:ln>
+        </p:spPr>
+      </p:pic>
+      <p:sp>
+        <p:nvSpPr>
+          <p:cNvPr id="10" name="Footer"/>
+          <p:cNvSpPr txBox="1"/>
+          <p:nvPr/>
+        </p:nvSpPr>
+        <p:spPr>
+          <a:xfrm>
+            <a:off x="685800" y="6250000"/>
+            <a:ext cx="10820400" cy="420000"/>
+          </a:xfrm>
+          <a:prstGeom prst="rect">
+            <a:avLst/>
+          </a:prstGeom>
+          <a:noFill/>
+          <a:ln>
+            <a:noFill/>
+          </a:ln>
+        </p:spPr>
+        <p:txBody>
+          <a:bodyPr wrap="square" lIns="182880" tIns="91440" rIns="182880" bIns="91440" anchor="t">
+            <a:normAutofit/>
+          </a:bodyPr>
+          <a:lstStyle/>
+          <a:p>
+            <a:pPr algn="l">
+              <a:lnSpc>
+                <a:spcPct val="105000"/>
+              </a:lnSpc>
+              <a:spcAft>
+                <a:spcPts val="0"/>
+              </a:spcAft>
+            </a:pPr>
+            <a:r>
               <a:rPr lang="en-US" sz="1000">
                 <a:solidFill>
-                  <a:srgbClr val="B0BDBA"/>
+                  <a:srgbClr val="6B717A"/>
                 </a:solidFill>
               </a:rPr>
               <a:t>Sources: Register now for PPCC 2026: Come for the learning, stay for the community</a:t>
-            </a:r>
-          </a:p>
-        </p:txBody>
-      </p:sp>
-      <p:sp>
-        <p:nvSpPr>
-          <p:cNvPr id="8" name="Slide number"/>
-          <p:cNvSpPr txBox="1"/>
-          <p:nvPr/>
-        </p:nvSpPr>
-        <p:spPr>
-          <a:xfrm>
-            <a:off x="10100000" y="6250000"/>
-            <a:ext cx="1400000" cy="420000"/>
-          </a:xfrm>
-          <a:prstGeom prst="rect">
-            <a:avLst/>
-          </a:prstGeom>
-          <a:noFill/>
-          <a:ln>
-            <a:noFill/>
-          </a:ln>
-        </p:spPr>
-        <p:txBody>
-          <a:bodyPr wrap="square" lIns="182880" tIns="91440" rIns="182880" bIns="91440" anchor="t">
-            <a:normAutofit/>
-          </a:bodyPr>
-          <a:lstStyle/>
-          <a:p>
-            <a:pPr algn="r"/>
-            <a:r>
-              <a:rPr lang="en-US" sz="1000">
-                <a:solidFill>
-                  <a:srgbClr val="B0BDBA"/>
-                </a:solidFill>
-              </a:rPr>
-              <a:t>2 / 6</a:t>
             </a:r>
           </a:p>
         </p:txBody>
@@ -1344,7 +1490,7 @@
     <p:bg>
       <p:bgPr>
         <a:solidFill>
-          <a:srgbClr val="071F1B"/>
+          <a:srgbClr val="F5F9F8"/>
         </a:solidFill>
         <a:effectLst/>
       </p:bgPr>
@@ -1358,20 +1504,20 @@
       <p:grpSpPr/>
       <p:sp>
         <p:nvSpPr>
-          <p:cNvPr id="2" name="Accent band"/>
+          <p:cNvPr id="2" name="Brand band"/>
           <p:cNvSpPr/>
           <p:nvPr/>
         </p:nvSpPr>
         <p:spPr>
           <a:xfrm>
             <a:off x="0" y="0"/>
-            <a:ext cx="12192000" cy="91440"/>
+            <a:ext cx="12192000" cy="502920"/>
           </a:xfrm>
           <a:prstGeom prst="rect">
             <a:avLst/>
           </a:prstGeom>
           <a:solidFill>
-            <a:srgbClr val="18A999"/>
+            <a:srgbClr val="0A172A"/>
           </a:solidFill>
           <a:ln>
             <a:noFill/>
@@ -1380,14 +1526,36 @@
       </p:sp>
       <p:sp>
         <p:nvSpPr>
-          <p:cNvPr id="3" name="Title"/>
-          <p:cNvSpPr txBox="1"/>
-          <p:nvPr/>
-        </p:nvSpPr>
-        <p:spPr>
-          <a:xfrm>
-            <a:off x="685800" y="420000"/>
-            <a:ext cx="10820400" cy="1150000"/>
+          <p:cNvPr id="3" name="Highlight rule"/>
+          <p:cNvSpPr/>
+          <p:nvPr/>
+        </p:nvSpPr>
+        <p:spPr>
+          <a:xfrm>
+            <a:off x="0" y="502920"/>
+            <a:ext cx="12192000" cy="45720"/>
+          </a:xfrm>
+          <a:prstGeom prst="rect">
+            <a:avLst/>
+          </a:prstGeom>
+          <a:solidFill>
+            <a:srgbClr val="2FFFE0"/>
+          </a:solidFill>
+          <a:ln>
+            <a:noFill/>
+          </a:ln>
+        </p:spPr>
+      </p:sp>
+      <p:sp>
+        <p:nvSpPr>
+          <p:cNvPr id="4" name="Deck kicker"/>
+          <p:cNvSpPr txBox="1"/>
+          <p:nvPr/>
+        </p:nvSpPr>
+        <p:spPr>
+          <a:xfrm>
+            <a:off x="685800" y="0"/>
+            <a:ext cx="8400000" cy="502920"/>
           </a:xfrm>
           <a:prstGeom prst="rect">
             <a:avLst/>
@@ -1412,37 +1580,74 @@
               </a:spcAft>
             </a:pPr>
             <a:r>
-              <a:rPr lang="en-US" sz="2900" b="1">
-                <a:solidFill>
-                  <a:srgbClr val="F2FBF8"/>
-                </a:solidFill>
-              </a:rPr>
-              <a:t>Use the full conference week deliberately</a:t>
-            </a:r>
-          </a:p>
-        </p:txBody>
-      </p:sp>
-      <p:sp>
-        <p:nvSpPr>
-          <p:cNvPr id="4" name="Body"/>
-          <p:cNvSpPr txBox="1"/>
-          <p:nvPr/>
-        </p:nvSpPr>
-        <p:spPr>
-          <a:xfrm>
-            <a:off x="685800" y="1750000"/>
-            <a:ext cx="3900000" cy="3900000"/>
-          </a:xfrm>
-          <a:prstGeom prst="rect">
-            <a:avLst/>
-          </a:prstGeom>
-          <a:noFill/>
-          <a:ln>
-            <a:noFill/>
-          </a:ln>
-        </p:spPr>
-        <p:txBody>
-          <a:bodyPr wrap="square" lIns="182880" tIns="91440" rIns="182880" bIns="91440" anchor="t">
+              <a:rPr lang="en-US" sz="1100" b="1" cap="all" spc="120">
+                <a:solidFill>
+                  <a:srgbClr val="FFFFFF"/>
+                </a:solidFill>
+              </a:rPr>
+              <a:t>PPCC 2026</a:t>
+            </a:r>
+          </a:p>
+        </p:txBody>
+      </p:sp>
+      <p:sp>
+        <p:nvSpPr>
+          <p:cNvPr id="5" name="Slide number"/>
+          <p:cNvSpPr txBox="1"/>
+          <p:nvPr/>
+        </p:nvSpPr>
+        <p:spPr>
+          <a:xfrm>
+            <a:off x="9100000" y="0"/>
+            <a:ext cx="2406400" cy="502920"/>
+          </a:xfrm>
+          <a:prstGeom prst="rect">
+            <a:avLst/>
+          </a:prstGeom>
+          <a:noFill/>
+          <a:ln>
+            <a:noFill/>
+          </a:ln>
+        </p:spPr>
+        <p:txBody>
+          <a:bodyPr wrap="square" lIns="182880" tIns="91440" rIns="182880" bIns="91440" anchor="ctr">
+            <a:normAutofit/>
+          </a:bodyPr>
+          <a:lstStyle/>
+          <a:p>
+            <a:pPr algn="r"/>
+            <a:r>
+              <a:rPr lang="en-US" sz="1100" b="1" cap="all" spc="120">
+                <a:solidFill>
+                  <a:srgbClr val="BABEC3"/>
+                </a:solidFill>
+              </a:rPr>
+              <a:t>3 / 6</a:t>
+            </a:r>
+          </a:p>
+        </p:txBody>
+      </p:sp>
+      <p:sp>
+        <p:nvSpPr>
+          <p:cNvPr id="6" name="Title"/>
+          <p:cNvSpPr txBox="1"/>
+          <p:nvPr/>
+        </p:nvSpPr>
+        <p:spPr>
+          <a:xfrm>
+            <a:off x="685800" y="700000"/>
+            <a:ext cx="10820400" cy="1150000"/>
+          </a:xfrm>
+          <a:prstGeom prst="rect">
+            <a:avLst/>
+          </a:prstGeom>
+          <a:noFill/>
+          <a:ln>
+            <a:noFill/>
+          </a:ln>
+        </p:spPr>
+        <p:txBody>
+          <a:bodyPr wrap="square" lIns="182880" tIns="91440" rIns="182880" bIns="91440" anchor="ctr">
             <a:normAutofit/>
           </a:bodyPr>
           <a:lstStyle/>
@@ -1456,77 +1661,27 @@
               </a:spcAft>
             </a:pPr>
             <a:r>
-              <a:rPr lang="en-US" sz="2600">
-                <a:solidFill>
-                  <a:srgbClr val="F2FBF8"/>
-                </a:solidFill>
-              </a:rPr>
-              <a:t>Main conference: October 27-29 at the MGM Grand in Las Vegas. Workshops: October 25-26 and October 30.</a:t>
-            </a:r>
-          </a:p>
-        </p:txBody>
-      </p:sp>
-      <p:sp>
-        <p:nvSpPr>
-          <p:cNvPr id="5" name="Accent rule"/>
-          <p:cNvSpPr/>
-          <p:nvPr/>
-        </p:nvSpPr>
-        <p:spPr>
-          <a:xfrm>
-            <a:off x="548640" y="1800000"/>
-            <a:ext cx="45720" cy="3800000"/>
-          </a:xfrm>
-          <a:prstGeom prst="rect">
-            <a:avLst/>
-          </a:prstGeom>
-          <a:solidFill>
-            <a:srgbClr val="18A999"/>
-          </a:solidFill>
-          <a:ln>
-            <a:noFill/>
-          </a:ln>
-        </p:spPr>
-      </p:sp>
-      <p:pic>
-        <p:nvPicPr>
-          <p:cNvPr id="6" name="Asset visual-conference-week" descr="Conference-week timeline: applied workshops bracket the October 27-29 main conference. (mermaid diagram)"/>
-          <p:cNvPicPr>
-            <a:picLocks noChangeAspect="1"/>
-          </p:cNvPicPr>
-          <p:nvPr/>
-        </p:nvPicPr>
-        <p:blipFill>
-          <a:blip r:embed="rIdImage1"/>
-          <a:stretch>
-            <a:fillRect/>
-          </a:stretch>
-        </p:blipFill>
-        <p:spPr>
-          <a:xfrm>
-            <a:off x="5000000" y="2021875"/>
-            <a:ext cx="6500000" cy="3656250"/>
-          </a:xfrm>
-          <a:prstGeom prst="rect">
-            <a:avLst/>
-          </a:prstGeom>
-          <a:ln>
-            <a:solidFill>
-              <a:srgbClr val="D9D9D9"/>
-            </a:solidFill>
-          </a:ln>
-        </p:spPr>
-      </p:pic>
-      <p:sp>
-        <p:nvSpPr>
-          <p:cNvPr id="7" name="Footer"/>
-          <p:cNvSpPr txBox="1"/>
-          <p:nvPr/>
-        </p:nvSpPr>
-        <p:spPr>
-          <a:xfrm>
-            <a:off x="685800" y="6250000"/>
-            <a:ext cx="9400000" cy="420000"/>
+              <a:rPr lang="en-US" sz="2900" b="1">
+                <a:solidFill>
+                  <a:srgbClr val="081222"/>
+                </a:solidFill>
+                <a:latin typeface="+mj-lt"/>
+              </a:rPr>
+              <a:t>Use the full conference week deliberately</a:t>
+            </a:r>
+          </a:p>
+        </p:txBody>
+      </p:sp>
+      <p:sp>
+        <p:nvSpPr>
+          <p:cNvPr id="7" name="Body"/>
+          <p:cNvSpPr txBox="1"/>
+          <p:nvPr/>
+        </p:nvSpPr>
+        <p:spPr>
+          <a:xfrm>
+            <a:off x="685800" y="1950000"/>
+            <a:ext cx="3900000" cy="3900000"/>
           </a:xfrm>
           <a:prstGeom prst="rect">
             <a:avLst/>
@@ -1551,49 +1706,107 @@
               </a:spcAft>
             </a:pPr>
             <a:r>
+              <a:rPr lang="en-US" sz="2600">
+                <a:solidFill>
+                  <a:srgbClr val="081222"/>
+                </a:solidFill>
+              </a:rPr>
+              <a:t>Main conference: October 27-29 at the MGM Grand in Las Vegas. Workshops: October 25-26 and October 30.</a:t>
+            </a:r>
+          </a:p>
+        </p:txBody>
+      </p:sp>
+      <p:sp>
+        <p:nvSpPr>
+          <p:cNvPr id="8" name="Accent rule"/>
+          <p:cNvSpPr/>
+          <p:nvPr/>
+        </p:nvSpPr>
+        <p:spPr>
+          <a:xfrm>
+            <a:off x="548640" y="2000000"/>
+            <a:ext cx="45720" cy="3800000"/>
+          </a:xfrm>
+          <a:prstGeom prst="rect">
+            <a:avLst/>
+          </a:prstGeom>
+          <a:solidFill>
+            <a:srgbClr val="17796A"/>
+          </a:solidFill>
+          <a:ln>
+            <a:noFill/>
+          </a:ln>
+        </p:spPr>
+      </p:sp>
+      <p:pic>
+        <p:nvPicPr>
+          <p:cNvPr id="9" name="Asset visual-conference-week" descr="Conference-week timeline: applied workshops bracket the October 27-29 main conference. (mermaid diagram)"/>
+          <p:cNvPicPr>
+            <a:picLocks noChangeAspect="1"/>
+          </p:cNvPicPr>
+          <p:nvPr/>
+        </p:nvPicPr>
+        <p:blipFill>
+          <a:blip r:embed="rIdImage1"/>
+          <a:stretch>
+            <a:fillRect/>
+          </a:stretch>
+        </p:blipFill>
+        <p:spPr>
+          <a:xfrm>
+            <a:off x="5000000" y="2221875"/>
+            <a:ext cx="6500000" cy="3656250"/>
+          </a:xfrm>
+          <a:prstGeom prst="rect">
+            <a:avLst/>
+          </a:prstGeom>
+          <a:ln>
+            <a:solidFill>
+              <a:srgbClr val="D9D9D9"/>
+            </a:solidFill>
+          </a:ln>
+        </p:spPr>
+      </p:pic>
+      <p:sp>
+        <p:nvSpPr>
+          <p:cNvPr id="10" name="Footer"/>
+          <p:cNvSpPr txBox="1"/>
+          <p:nvPr/>
+        </p:nvSpPr>
+        <p:spPr>
+          <a:xfrm>
+            <a:off x="685800" y="6250000"/>
+            <a:ext cx="10820400" cy="420000"/>
+          </a:xfrm>
+          <a:prstGeom prst="rect">
+            <a:avLst/>
+          </a:prstGeom>
+          <a:noFill/>
+          <a:ln>
+            <a:noFill/>
+          </a:ln>
+        </p:spPr>
+        <p:txBody>
+          <a:bodyPr wrap="square" lIns="182880" tIns="91440" rIns="182880" bIns="91440" anchor="t">
+            <a:normAutofit/>
+          </a:bodyPr>
+          <a:lstStyle/>
+          <a:p>
+            <a:pPr algn="l">
+              <a:lnSpc>
+                <a:spcPct val="105000"/>
+              </a:lnSpc>
+              <a:spcAft>
+                <a:spcPts val="0"/>
+              </a:spcAft>
+            </a:pPr>
+            <a:r>
               <a:rPr lang="en-US" sz="1000">
                 <a:solidFill>
-                  <a:srgbClr val="B0BDBA"/>
+                  <a:srgbClr val="6B717A"/>
                 </a:solidFill>
               </a:rPr>
               <a:t>Sources: Register now for PPCC 2026: Come for the learning, stay for the community  ·  FAQ | PPCC26</a:t>
-            </a:r>
-          </a:p>
-        </p:txBody>
-      </p:sp>
-      <p:sp>
-        <p:nvSpPr>
-          <p:cNvPr id="8" name="Slide number"/>
-          <p:cNvSpPr txBox="1"/>
-          <p:nvPr/>
-        </p:nvSpPr>
-        <p:spPr>
-          <a:xfrm>
-            <a:off x="10100000" y="6250000"/>
-            <a:ext cx="1400000" cy="420000"/>
-          </a:xfrm>
-          <a:prstGeom prst="rect">
-            <a:avLst/>
-          </a:prstGeom>
-          <a:noFill/>
-          <a:ln>
-            <a:noFill/>
-          </a:ln>
-        </p:spPr>
-        <p:txBody>
-          <a:bodyPr wrap="square" lIns="182880" tIns="91440" rIns="182880" bIns="91440" anchor="t">
-            <a:normAutofit/>
-          </a:bodyPr>
-          <a:lstStyle/>
-          <a:p>
-            <a:pPr algn="r"/>
-            <a:r>
-              <a:rPr lang="en-US" sz="1000">
-                <a:solidFill>
-                  <a:srgbClr val="B0BDBA"/>
-                </a:solidFill>
-              </a:rPr>
-              <a:t>3 / 6</a:t>
             </a:r>
           </a:p>
         </p:txBody>
@@ -1612,7 +1825,7 @@
     <p:bg>
       <p:bgPr>
         <a:solidFill>
-          <a:srgbClr val="071F1B"/>
+          <a:srgbClr val="F5F9F8"/>
         </a:solidFill>
         <a:effectLst/>
       </p:bgPr>
@@ -1626,20 +1839,20 @@
       <p:grpSpPr/>
       <p:sp>
         <p:nvSpPr>
-          <p:cNvPr id="2" name="Accent band"/>
+          <p:cNvPr id="2" name="Brand band"/>
           <p:cNvSpPr/>
           <p:nvPr/>
         </p:nvSpPr>
         <p:spPr>
           <a:xfrm>
             <a:off x="0" y="0"/>
-            <a:ext cx="12192000" cy="91440"/>
+            <a:ext cx="12192000" cy="502920"/>
           </a:xfrm>
           <a:prstGeom prst="rect">
             <a:avLst/>
           </a:prstGeom>
           <a:solidFill>
-            <a:srgbClr val="18A999"/>
+            <a:srgbClr val="0A172A"/>
           </a:solidFill>
           <a:ln>
             <a:noFill/>
@@ -1648,14 +1861,36 @@
       </p:sp>
       <p:sp>
         <p:nvSpPr>
-          <p:cNvPr id="3" name="Title"/>
-          <p:cNvSpPr txBox="1"/>
-          <p:nvPr/>
-        </p:nvSpPr>
-        <p:spPr>
-          <a:xfrm>
-            <a:off x="685800" y="420000"/>
-            <a:ext cx="10820400" cy="1150000"/>
+          <p:cNvPr id="3" name="Highlight rule"/>
+          <p:cNvSpPr/>
+          <p:nvPr/>
+        </p:nvSpPr>
+        <p:spPr>
+          <a:xfrm>
+            <a:off x="0" y="502920"/>
+            <a:ext cx="12192000" cy="45720"/>
+          </a:xfrm>
+          <a:prstGeom prst="rect">
+            <a:avLst/>
+          </a:prstGeom>
+          <a:solidFill>
+            <a:srgbClr val="2FFFE0"/>
+          </a:solidFill>
+          <a:ln>
+            <a:noFill/>
+          </a:ln>
+        </p:spPr>
+      </p:sp>
+      <p:sp>
+        <p:nvSpPr>
+          <p:cNvPr id="4" name="Deck kicker"/>
+          <p:cNvSpPr txBox="1"/>
+          <p:nvPr/>
+        </p:nvSpPr>
+        <p:spPr>
+          <a:xfrm>
+            <a:off x="685800" y="0"/>
+            <a:ext cx="8400000" cy="502920"/>
           </a:xfrm>
           <a:prstGeom prst="rect">
             <a:avLst/>
@@ -1680,37 +1915,74 @@
               </a:spcAft>
             </a:pPr>
             <a:r>
-              <a:rPr lang="en-US" sz="2900" b="1">
-                <a:solidFill>
-                  <a:srgbClr val="F2FBF8"/>
-                </a:solidFill>
-              </a:rPr>
-              <a:t>Connect innovation ambition to execution controls</a:t>
-            </a:r>
-          </a:p>
-        </p:txBody>
-      </p:sp>
-      <p:sp>
-        <p:nvSpPr>
-          <p:cNvPr id="4" name="Body"/>
-          <p:cNvSpPr txBox="1"/>
-          <p:nvPr/>
-        </p:nvSpPr>
-        <p:spPr>
-          <a:xfrm>
-            <a:off x="685800" y="1750000"/>
-            <a:ext cx="3900000" cy="3900000"/>
-          </a:xfrm>
-          <a:prstGeom prst="rect">
-            <a:avLst/>
-          </a:prstGeom>
-          <a:noFill/>
-          <a:ln>
-            <a:noFill/>
-          </a:ln>
-        </p:spPr>
-        <p:txBody>
-          <a:bodyPr wrap="square" lIns="182880" tIns="91440" rIns="182880" bIns="91440" anchor="t">
+              <a:rPr lang="en-US" sz="1100" b="1" cap="all" spc="120">
+                <a:solidFill>
+                  <a:srgbClr val="FFFFFF"/>
+                </a:solidFill>
+              </a:rPr>
+              <a:t>PPCC 2026</a:t>
+            </a:r>
+          </a:p>
+        </p:txBody>
+      </p:sp>
+      <p:sp>
+        <p:nvSpPr>
+          <p:cNvPr id="5" name="Slide number"/>
+          <p:cNvSpPr txBox="1"/>
+          <p:nvPr/>
+        </p:nvSpPr>
+        <p:spPr>
+          <a:xfrm>
+            <a:off x="9100000" y="0"/>
+            <a:ext cx="2406400" cy="502920"/>
+          </a:xfrm>
+          <a:prstGeom prst="rect">
+            <a:avLst/>
+          </a:prstGeom>
+          <a:noFill/>
+          <a:ln>
+            <a:noFill/>
+          </a:ln>
+        </p:spPr>
+        <p:txBody>
+          <a:bodyPr wrap="square" lIns="182880" tIns="91440" rIns="182880" bIns="91440" anchor="ctr">
+            <a:normAutofit/>
+          </a:bodyPr>
+          <a:lstStyle/>
+          <a:p>
+            <a:pPr algn="r"/>
+            <a:r>
+              <a:rPr lang="en-US" sz="1100" b="1" cap="all" spc="120">
+                <a:solidFill>
+                  <a:srgbClr val="BABEC3"/>
+                </a:solidFill>
+              </a:rPr>
+              <a:t>4 / 6</a:t>
+            </a:r>
+          </a:p>
+        </p:txBody>
+      </p:sp>
+      <p:sp>
+        <p:nvSpPr>
+          <p:cNvPr id="6" name="Title"/>
+          <p:cNvSpPr txBox="1"/>
+          <p:nvPr/>
+        </p:nvSpPr>
+        <p:spPr>
+          <a:xfrm>
+            <a:off x="685800" y="700000"/>
+            <a:ext cx="10820400" cy="1150000"/>
+          </a:xfrm>
+          <a:prstGeom prst="rect">
+            <a:avLst/>
+          </a:prstGeom>
+          <a:noFill/>
+          <a:ln>
+            <a:noFill/>
+          </a:ln>
+        </p:spPr>
+        <p:txBody>
+          <a:bodyPr wrap="square" lIns="182880" tIns="91440" rIns="182880" bIns="91440" anchor="ctr">
             <a:normAutofit/>
           </a:bodyPr>
           <a:lstStyle/>
@@ -1724,77 +1996,27 @@
               </a:spcAft>
             </a:pPr>
             <a:r>
-              <a:rPr lang="en-US" sz="2600">
-                <a:solidFill>
-                  <a:srgbClr val="F2FBF8"/>
-                </a:solidFill>
-              </a:rPr>
-              <a:t>PPCC connects agents, apps, automation, and trusted data with implementation, architecture, governance, and AI-driven scenarios.</a:t>
-            </a:r>
-          </a:p>
-        </p:txBody>
-      </p:sp>
-      <p:sp>
-        <p:nvSpPr>
-          <p:cNvPr id="5" name="Accent rule"/>
-          <p:cNvSpPr/>
-          <p:nvPr/>
-        </p:nvSpPr>
-        <p:spPr>
-          <a:xfrm>
-            <a:off x="548640" y="1800000"/>
-            <a:ext cx="45720" cy="3800000"/>
-          </a:xfrm>
-          <a:prstGeom prst="rect">
-            <a:avLst/>
-          </a:prstGeom>
-          <a:solidFill>
-            <a:srgbClr val="18A999"/>
-          </a:solidFill>
-          <a:ln>
-            <a:noFill/>
-          </a:ln>
-        </p:spPr>
-      </p:sp>
-      <p:pic>
-        <p:nvPicPr>
-          <p:cNvPr id="6" name="Asset visual-execution-value" descr="Learning-to-pilot flow: narrow the opportunity, ground it in trusted data, set controls, then test. (mermaid diagram)"/>
-          <p:cNvPicPr>
-            <a:picLocks noChangeAspect="1"/>
-          </p:cNvPicPr>
-          <p:nvPr/>
-        </p:nvPicPr>
-        <p:blipFill>
-          <a:blip r:embed="rIdImage1"/>
-          <a:stretch>
-            <a:fillRect/>
-          </a:stretch>
-        </p:blipFill>
-        <p:spPr>
-          <a:xfrm>
-            <a:off x="5000000" y="2021875"/>
-            <a:ext cx="6500000" cy="3656250"/>
-          </a:xfrm>
-          <a:prstGeom prst="rect">
-            <a:avLst/>
-          </a:prstGeom>
-          <a:ln>
-            <a:solidFill>
-              <a:srgbClr val="D9D9D9"/>
-            </a:solidFill>
-          </a:ln>
-        </p:spPr>
-      </p:pic>
-      <p:sp>
-        <p:nvSpPr>
-          <p:cNvPr id="7" name="Footer"/>
-          <p:cNvSpPr txBox="1"/>
-          <p:nvPr/>
-        </p:nvSpPr>
-        <p:spPr>
-          <a:xfrm>
-            <a:off x="685800" y="6250000"/>
-            <a:ext cx="9400000" cy="420000"/>
+              <a:rPr lang="en-US" sz="2900" b="1">
+                <a:solidFill>
+                  <a:srgbClr val="081222"/>
+                </a:solidFill>
+                <a:latin typeface="+mj-lt"/>
+              </a:rPr>
+              <a:t>Connect innovation ambition to execution controls</a:t>
+            </a:r>
+          </a:p>
+        </p:txBody>
+      </p:sp>
+      <p:sp>
+        <p:nvSpPr>
+          <p:cNvPr id="7" name="Body"/>
+          <p:cNvSpPr txBox="1"/>
+          <p:nvPr/>
+        </p:nvSpPr>
+        <p:spPr>
+          <a:xfrm>
+            <a:off x="685800" y="1950000"/>
+            <a:ext cx="3900000" cy="3900000"/>
           </a:xfrm>
           <a:prstGeom prst="rect">
             <a:avLst/>
@@ -1819,49 +2041,107 @@
               </a:spcAft>
             </a:pPr>
             <a:r>
+              <a:rPr lang="en-US" sz="2600">
+                <a:solidFill>
+                  <a:srgbClr val="081222"/>
+                </a:solidFill>
+              </a:rPr>
+              <a:t>PPCC connects agents, apps, automation, and trusted data with implementation, architecture, governance, and AI-driven scenarios.</a:t>
+            </a:r>
+          </a:p>
+        </p:txBody>
+      </p:sp>
+      <p:sp>
+        <p:nvSpPr>
+          <p:cNvPr id="8" name="Accent rule"/>
+          <p:cNvSpPr/>
+          <p:nvPr/>
+        </p:nvSpPr>
+        <p:spPr>
+          <a:xfrm>
+            <a:off x="548640" y="2000000"/>
+            <a:ext cx="45720" cy="3800000"/>
+          </a:xfrm>
+          <a:prstGeom prst="rect">
+            <a:avLst/>
+          </a:prstGeom>
+          <a:solidFill>
+            <a:srgbClr val="17796A"/>
+          </a:solidFill>
+          <a:ln>
+            <a:noFill/>
+          </a:ln>
+        </p:spPr>
+      </p:sp>
+      <p:pic>
+        <p:nvPicPr>
+          <p:cNvPr id="9" name="Asset visual-execution-value" descr="Learning-to-pilot flow: narrow the opportunity, ground it in trusted data, set controls, then test. (mermaid diagram)"/>
+          <p:cNvPicPr>
+            <a:picLocks noChangeAspect="1"/>
+          </p:cNvPicPr>
+          <p:nvPr/>
+        </p:nvPicPr>
+        <p:blipFill>
+          <a:blip r:embed="rIdImage1"/>
+          <a:stretch>
+            <a:fillRect/>
+          </a:stretch>
+        </p:blipFill>
+        <p:spPr>
+          <a:xfrm>
+            <a:off x="5000000" y="2221875"/>
+            <a:ext cx="6500000" cy="3656250"/>
+          </a:xfrm>
+          <a:prstGeom prst="rect">
+            <a:avLst/>
+          </a:prstGeom>
+          <a:ln>
+            <a:solidFill>
+              <a:srgbClr val="D9D9D9"/>
+            </a:solidFill>
+          </a:ln>
+        </p:spPr>
+      </p:pic>
+      <p:sp>
+        <p:nvSpPr>
+          <p:cNvPr id="10" name="Footer"/>
+          <p:cNvSpPr txBox="1"/>
+          <p:nvPr/>
+        </p:nvSpPr>
+        <p:spPr>
+          <a:xfrm>
+            <a:off x="685800" y="6250000"/>
+            <a:ext cx="10820400" cy="420000"/>
+          </a:xfrm>
+          <a:prstGeom prst="rect">
+            <a:avLst/>
+          </a:prstGeom>
+          <a:noFill/>
+          <a:ln>
+            <a:noFill/>
+          </a:ln>
+        </p:spPr>
+        <p:txBody>
+          <a:bodyPr wrap="square" lIns="182880" tIns="91440" rIns="182880" bIns="91440" anchor="t">
+            <a:normAutofit/>
+          </a:bodyPr>
+          <a:lstStyle/>
+          <a:p>
+            <a:pPr algn="l">
+              <a:lnSpc>
+                <a:spcPct val="105000"/>
+              </a:lnSpc>
+              <a:spcAft>
+                <a:spcPts val="0"/>
+              </a:spcAft>
+            </a:pPr>
+            <a:r>
               <a:rPr lang="en-US" sz="1000">
                 <a:solidFill>
-                  <a:srgbClr val="B0BDBA"/>
+                  <a:srgbClr val="6B717A"/>
                 </a:solidFill>
               </a:rPr>
               <a:t>Sources: Register now for PPCC 2026: Come for the learning, stay for the community  ·  FAQ | PPCC26</a:t>
-            </a:r>
-          </a:p>
-        </p:txBody>
-      </p:sp>
-      <p:sp>
-        <p:nvSpPr>
-          <p:cNvPr id="8" name="Slide number"/>
-          <p:cNvSpPr txBox="1"/>
-          <p:nvPr/>
-        </p:nvSpPr>
-        <p:spPr>
-          <a:xfrm>
-            <a:off x="10100000" y="6250000"/>
-            <a:ext cx="1400000" cy="420000"/>
-          </a:xfrm>
-          <a:prstGeom prst="rect">
-            <a:avLst/>
-          </a:prstGeom>
-          <a:noFill/>
-          <a:ln>
-            <a:noFill/>
-          </a:ln>
-        </p:spPr>
-        <p:txBody>
-          <a:bodyPr wrap="square" lIns="182880" tIns="91440" rIns="182880" bIns="91440" anchor="t">
-            <a:normAutofit/>
-          </a:bodyPr>
-          <a:lstStyle/>
-          <a:p>
-            <a:pPr algn="r"/>
-            <a:r>
-              <a:rPr lang="en-US" sz="1000">
-                <a:solidFill>
-                  <a:srgbClr val="B0BDBA"/>
-                </a:solidFill>
-              </a:rPr>
-              <a:t>4 / 6</a:t>
             </a:r>
           </a:p>
         </p:txBody>
@@ -1880,7 +2160,7 @@
     <p:bg>
       <p:bgPr>
         <a:solidFill>
-          <a:srgbClr val="071F1B"/>
+          <a:srgbClr val="F5F9F8"/>
         </a:solidFill>
         <a:effectLst/>
       </p:bgPr>
@@ -1894,20 +2174,20 @@
       <p:grpSpPr/>
       <p:sp>
         <p:nvSpPr>
-          <p:cNvPr id="2" name="Accent band"/>
+          <p:cNvPr id="2" name="Brand band"/>
           <p:cNvSpPr/>
           <p:nvPr/>
         </p:nvSpPr>
         <p:spPr>
           <a:xfrm>
             <a:off x="0" y="0"/>
-            <a:ext cx="12192000" cy="91440"/>
+            <a:ext cx="12192000" cy="502920"/>
           </a:xfrm>
           <a:prstGeom prst="rect">
             <a:avLst/>
           </a:prstGeom>
           <a:solidFill>
-            <a:srgbClr val="18A999"/>
+            <a:srgbClr val="0A172A"/>
           </a:solidFill>
           <a:ln>
             <a:noFill/>
@@ -1916,14 +2196,36 @@
       </p:sp>
       <p:sp>
         <p:nvSpPr>
-          <p:cNvPr id="3" name="Title"/>
-          <p:cNvSpPr txBox="1"/>
-          <p:nvPr/>
-        </p:nvSpPr>
-        <p:spPr>
-          <a:xfrm>
-            <a:off x="685800" y="420000"/>
-            <a:ext cx="10820400" cy="1150000"/>
+          <p:cNvPr id="3" name="Highlight rule"/>
+          <p:cNvSpPr/>
+          <p:nvPr/>
+        </p:nvSpPr>
+        <p:spPr>
+          <a:xfrm>
+            <a:off x="0" y="502920"/>
+            <a:ext cx="12192000" cy="45720"/>
+          </a:xfrm>
+          <a:prstGeom prst="rect">
+            <a:avLst/>
+          </a:prstGeom>
+          <a:solidFill>
+            <a:srgbClr val="2FFFE0"/>
+          </a:solidFill>
+          <a:ln>
+            <a:noFill/>
+          </a:ln>
+        </p:spPr>
+      </p:sp>
+      <p:sp>
+        <p:nvSpPr>
+          <p:cNvPr id="4" name="Deck kicker"/>
+          <p:cNvSpPr txBox="1"/>
+          <p:nvPr/>
+        </p:nvSpPr>
+        <p:spPr>
+          <a:xfrm>
+            <a:off x="685800" y="0"/>
+            <a:ext cx="8400000" cy="502920"/>
           </a:xfrm>
           <a:prstGeom prst="rect">
             <a:avLst/>
@@ -1948,37 +2250,74 @@
               </a:spcAft>
             </a:pPr>
             <a:r>
-              <a:rPr lang="en-US" sz="2900" b="1">
-                <a:solidFill>
-                  <a:srgbClr val="F2FBF8"/>
-                </a:solidFill>
-              </a:rPr>
-              <a:t>Require one pilot charter after the event</a:t>
-            </a:r>
-          </a:p>
-        </p:txBody>
-      </p:sp>
-      <p:sp>
-        <p:nvSpPr>
-          <p:cNvPr id="4" name="Body"/>
-          <p:cNvSpPr txBox="1"/>
-          <p:nvPr/>
-        </p:nvSpPr>
-        <p:spPr>
-          <a:xfrm>
-            <a:off x="685800" y="1750000"/>
-            <a:ext cx="5300000" cy="3900000"/>
-          </a:xfrm>
-          <a:prstGeom prst="rect">
-            <a:avLst/>
-          </a:prstGeom>
-          <a:noFill/>
-          <a:ln>
-            <a:noFill/>
-          </a:ln>
-        </p:spPr>
-        <p:txBody>
-          <a:bodyPr wrap="square" lIns="182880" tIns="91440" rIns="182880" bIns="91440" anchor="t">
+              <a:rPr lang="en-US" sz="1100" b="1" cap="all" spc="120">
+                <a:solidFill>
+                  <a:srgbClr val="FFFFFF"/>
+                </a:solidFill>
+              </a:rPr>
+              <a:t>PPCC 2026</a:t>
+            </a:r>
+          </a:p>
+        </p:txBody>
+      </p:sp>
+      <p:sp>
+        <p:nvSpPr>
+          <p:cNvPr id="5" name="Slide number"/>
+          <p:cNvSpPr txBox="1"/>
+          <p:nvPr/>
+        </p:nvSpPr>
+        <p:spPr>
+          <a:xfrm>
+            <a:off x="9100000" y="0"/>
+            <a:ext cx="2406400" cy="502920"/>
+          </a:xfrm>
+          <a:prstGeom prst="rect">
+            <a:avLst/>
+          </a:prstGeom>
+          <a:noFill/>
+          <a:ln>
+            <a:noFill/>
+          </a:ln>
+        </p:spPr>
+        <p:txBody>
+          <a:bodyPr wrap="square" lIns="182880" tIns="91440" rIns="182880" bIns="91440" anchor="ctr">
+            <a:normAutofit/>
+          </a:bodyPr>
+          <a:lstStyle/>
+          <a:p>
+            <a:pPr algn="r"/>
+            <a:r>
+              <a:rPr lang="en-US" sz="1100" b="1" cap="all" spc="120">
+                <a:solidFill>
+                  <a:srgbClr val="BABEC3"/>
+                </a:solidFill>
+              </a:rPr>
+              <a:t>5 / 6</a:t>
+            </a:r>
+          </a:p>
+        </p:txBody>
+      </p:sp>
+      <p:sp>
+        <p:nvSpPr>
+          <p:cNvPr id="6" name="Title"/>
+          <p:cNvSpPr txBox="1"/>
+          <p:nvPr/>
+        </p:nvSpPr>
+        <p:spPr>
+          <a:xfrm>
+            <a:off x="685800" y="700000"/>
+            <a:ext cx="10820400" cy="1150000"/>
+          </a:xfrm>
+          <a:prstGeom prst="rect">
+            <a:avLst/>
+          </a:prstGeom>
+          <a:noFill/>
+          <a:ln>
+            <a:noFill/>
+          </a:ln>
+        </p:spPr>
+        <p:txBody>
+          <a:bodyPr wrap="square" lIns="182880" tIns="91440" rIns="182880" bIns="91440" anchor="ctr">
             <a:normAutofit/>
           </a:bodyPr>
           <a:lstStyle/>
@@ -1992,9 +2331,54 @@
               </a:spcAft>
             </a:pPr>
             <a:r>
+              <a:rPr lang="en-US" sz="2900" b="1">
+                <a:solidFill>
+                  <a:srgbClr val="081222"/>
+                </a:solidFill>
+                <a:latin typeface="+mj-lt"/>
+              </a:rPr>
+              <a:t>Require one pilot charter after the event</a:t>
+            </a:r>
+          </a:p>
+        </p:txBody>
+      </p:sp>
+      <p:sp>
+        <p:nvSpPr>
+          <p:cNvPr id="7" name="Body"/>
+          <p:cNvSpPr txBox="1"/>
+          <p:nvPr/>
+        </p:nvSpPr>
+        <p:spPr>
+          <a:xfrm>
+            <a:off x="685800" y="1950000"/>
+            <a:ext cx="5300000" cy="3900000"/>
+          </a:xfrm>
+          <a:prstGeom prst="rect">
+            <a:avLst/>
+          </a:prstGeom>
+          <a:noFill/>
+          <a:ln>
+            <a:noFill/>
+          </a:ln>
+        </p:spPr>
+        <p:txBody>
+          <a:bodyPr wrap="square" lIns="182880" tIns="91440" rIns="182880" bIns="91440" anchor="t">
+            <a:normAutofit/>
+          </a:bodyPr>
+          <a:lstStyle/>
+          <a:p>
+            <a:pPr algn="l">
+              <a:lnSpc>
+                <a:spcPct val="105000"/>
+              </a:lnSpc>
+              <a:spcAft>
+                <a:spcPts val="0"/>
+              </a:spcAft>
+            </a:pPr>
+            <a:r>
               <a:rPr lang="en-US" sz="2600">
                 <a:solidFill>
-                  <a:srgbClr val="F2FBF8"/>
+                  <a:srgbClr val="081222"/>
                 </a:solidFill>
               </a:rPr>
               <a:t>Ask the team to return with the workflow, owner, trusted data, guardrails, and testable success measure for one pilot. Expansion should depend on that evidence, not conference enthusiasm.</a:t>
@@ -2004,20 +2388,20 @@
       </p:sp>
       <p:sp>
         <p:nvSpPr>
-          <p:cNvPr id="5" name="Accent rule"/>
+          <p:cNvPr id="8" name="Accent rule"/>
           <p:cNvSpPr/>
           <p:nvPr/>
         </p:nvSpPr>
         <p:spPr>
           <a:xfrm>
-            <a:off x="548640" y="1800000"/>
+            <a:off x="548640" y="2000000"/>
             <a:ext cx="45720" cy="3800000"/>
           </a:xfrm>
           <a:prstGeom prst="rect">
             <a:avLst/>
           </a:prstGeom>
           <a:solidFill>
-            <a:srgbClr val="18A999"/>
+            <a:srgbClr val="17796A"/>
           </a:solidFill>
           <a:ln>
             <a:noFill/>
@@ -2026,26 +2410,26 @@
       </p:sp>
       <p:sp>
         <p:nvSpPr>
-          <p:cNvPr id="6" name="Claim 1"/>
+          <p:cNvPr id="9" name="Claim 1"/>
           <p:cNvSpPr/>
           <p:nvPr/>
         </p:nvSpPr>
         <p:spPr>
           <a:xfrm>
-            <a:off x="6400000" y="1750000"/>
+            <a:off x="6400000" y="1950000"/>
             <a:ext cx="5105000" cy="1500000"/>
           </a:xfrm>
           <a:prstGeom prst="roundRect">
             <a:avLst>
-              <a:gd name="adj" fmla="val 9000"/>
+              <a:gd name="adj" fmla="val 6000"/>
             </a:avLst>
           </a:prstGeom>
           <a:solidFill>
-            <a:srgbClr val="1A312D"/>
+            <a:srgbClr val="FFFFFF"/>
           </a:solidFill>
           <a:ln w="12700">
             <a:solidFill>
-              <a:srgbClr val="314743"/>
+              <a:srgbClr val="C8D8D5"/>
             </a:solidFill>
           </a:ln>
         </p:spPr>
@@ -2066,7 +2450,7 @@
             <a:r>
               <a:rPr lang="en-US" sz="1500">
                 <a:solidFill>
-                  <a:srgbClr val="F2FBF8"/>
+                  <a:srgbClr val="081222"/>
                 </a:solidFill>
               </a:rPr>
               <a:t>The FAQ emphasizes implementation, architecture, governance, and AI-driven scenarios.</a:t>
@@ -2084,7 +2468,7 @@
             <a:r>
               <a:rPr lang="en-US" sz="1100">
                 <a:solidFill>
-                  <a:srgbClr val="B0BDBA"/>
+                  <a:srgbClr val="6B717A"/>
                 </a:solidFill>
               </a:rPr>
               <a:t>FAQ | PPCC26</a:t>
@@ -2094,14 +2478,14 @@
       </p:sp>
       <p:sp>
         <p:nvSpPr>
-          <p:cNvPr id="7" name="Footer"/>
+          <p:cNvPr id="10" name="Footer"/>
           <p:cNvSpPr txBox="1"/>
           <p:nvPr/>
         </p:nvSpPr>
         <p:spPr>
           <a:xfrm>
             <a:off x="685800" y="6250000"/>
-            <a:ext cx="9400000" cy="420000"/>
+            <a:ext cx="10820400" cy="420000"/>
           </a:xfrm>
           <a:prstGeom prst="rect">
             <a:avLst/>
@@ -2128,47 +2512,10 @@
             <a:r>
               <a:rPr lang="en-US" sz="1000">
                 <a:solidFill>
-                  <a:srgbClr val="B0BDBA"/>
+                  <a:srgbClr val="6B717A"/>
                 </a:solidFill>
               </a:rPr>
               <a:t>Sources: FAQ | PPCC26</a:t>
-            </a:r>
-          </a:p>
-        </p:txBody>
-      </p:sp>
-      <p:sp>
-        <p:nvSpPr>
-          <p:cNvPr id="8" name="Slide number"/>
-          <p:cNvSpPr txBox="1"/>
-          <p:nvPr/>
-        </p:nvSpPr>
-        <p:spPr>
-          <a:xfrm>
-            <a:off x="10100000" y="6250000"/>
-            <a:ext cx="1400000" cy="420000"/>
-          </a:xfrm>
-          <a:prstGeom prst="rect">
-            <a:avLst/>
-          </a:prstGeom>
-          <a:noFill/>
-          <a:ln>
-            <a:noFill/>
-          </a:ln>
-        </p:spPr>
-        <p:txBody>
-          <a:bodyPr wrap="square" lIns="182880" tIns="91440" rIns="182880" bIns="91440" anchor="t">
-            <a:normAutofit/>
-          </a:bodyPr>
-          <a:lstStyle/>
-          <a:p>
-            <a:pPr algn="r"/>
-            <a:r>
-              <a:rPr lang="en-US" sz="1000">
-                <a:solidFill>
-                  <a:srgbClr val="B0BDBA"/>
-                </a:solidFill>
-              </a:rPr>
-              <a:t>5 / 6</a:t>
             </a:r>
           </a:p>
         </p:txBody>
@@ -2187,7 +2534,7 @@
     <p:bg>
       <p:bgPr>
         <a:solidFill>
-          <a:srgbClr val="071F1B"/>
+          <a:srgbClr val="F5F9F8"/>
         </a:solidFill>
         <a:effectLst/>
       </p:bgPr>
@@ -2201,20 +2548,20 @@
       <p:grpSpPr/>
       <p:sp>
         <p:nvSpPr>
-          <p:cNvPr id="2" name="Accent band"/>
+          <p:cNvPr id="2" name="Brand band"/>
           <p:cNvSpPr/>
           <p:nvPr/>
         </p:nvSpPr>
         <p:spPr>
           <a:xfrm>
             <a:off x="0" y="0"/>
-            <a:ext cx="12192000" cy="91440"/>
+            <a:ext cx="12192000" cy="502920"/>
           </a:xfrm>
           <a:prstGeom prst="rect">
             <a:avLst/>
           </a:prstGeom>
           <a:solidFill>
-            <a:srgbClr val="18A999"/>
+            <a:srgbClr val="0A172A"/>
           </a:solidFill>
           <a:ln>
             <a:noFill/>
@@ -2223,14 +2570,36 @@
       </p:sp>
       <p:sp>
         <p:nvSpPr>
-          <p:cNvPr id="3" name="Title"/>
-          <p:cNvSpPr txBox="1"/>
-          <p:nvPr/>
-        </p:nvSpPr>
-        <p:spPr>
-          <a:xfrm>
-            <a:off x="685800" y="420000"/>
-            <a:ext cx="10820400" cy="1000000"/>
+          <p:cNvPr id="3" name="Highlight rule"/>
+          <p:cNvSpPr/>
+          <p:nvPr/>
+        </p:nvSpPr>
+        <p:spPr>
+          <a:xfrm>
+            <a:off x="0" y="502920"/>
+            <a:ext cx="12192000" cy="45720"/>
+          </a:xfrm>
+          <a:prstGeom prst="rect">
+            <a:avLst/>
+          </a:prstGeom>
+          <a:solidFill>
+            <a:srgbClr val="2FFFE0"/>
+          </a:solidFill>
+          <a:ln>
+            <a:noFill/>
+          </a:ln>
+        </p:spPr>
+      </p:sp>
+      <p:sp>
+        <p:nvSpPr>
+          <p:cNvPr id="4" name="Deck kicker"/>
+          <p:cNvSpPr txBox="1"/>
+          <p:nvPr/>
+        </p:nvSpPr>
+        <p:spPr>
+          <a:xfrm>
+            <a:off x="685800" y="0"/>
+            <a:ext cx="8400000" cy="502920"/>
           </a:xfrm>
           <a:prstGeom prst="rect">
             <a:avLst/>
@@ -2255,45 +2624,74 @@
               </a:spcAft>
             </a:pPr>
             <a:r>
-              <a:rPr lang="en-US" sz="2400" b="1">
-                <a:solidFill>
-                  <a:srgbClr val="F2FBF8"/>
-                </a:solidFill>
-              </a:rPr>
-              <a:t>Sources.</a:t>
-            </a:r>
-            <a:r>
-              <a:rPr lang="en-US" sz="2400" b="1">
-                <a:solidFill>
-                  <a:srgbClr val="18A999"/>
-                </a:solidFill>
-              </a:rPr>
-              <a:t> Every claim traces to one.</a:t>
-            </a:r>
-          </a:p>
-        </p:txBody>
-      </p:sp>
-      <p:sp>
-        <p:nvSpPr>
-          <p:cNvPr id="4" name="Sources"/>
-          <p:cNvSpPr txBox="1"/>
-          <p:nvPr/>
-        </p:nvSpPr>
-        <p:spPr>
-          <a:xfrm>
-            <a:off x="685800" y="1700000"/>
-            <a:ext cx="10820400" cy="4300000"/>
-          </a:xfrm>
-          <a:prstGeom prst="rect">
-            <a:avLst/>
-          </a:prstGeom>
-          <a:noFill/>
-          <a:ln>
-            <a:noFill/>
-          </a:ln>
-        </p:spPr>
-        <p:txBody>
-          <a:bodyPr wrap="square" lIns="182880" tIns="91440" rIns="182880" bIns="91440" anchor="t">
+              <a:rPr lang="en-US" sz="1100" b="1" cap="all" spc="120">
+                <a:solidFill>
+                  <a:srgbClr val="FFFFFF"/>
+                </a:solidFill>
+              </a:rPr>
+              <a:t>PPCC 2026</a:t>
+            </a:r>
+          </a:p>
+        </p:txBody>
+      </p:sp>
+      <p:sp>
+        <p:nvSpPr>
+          <p:cNvPr id="5" name="Slide number"/>
+          <p:cNvSpPr txBox="1"/>
+          <p:nvPr/>
+        </p:nvSpPr>
+        <p:spPr>
+          <a:xfrm>
+            <a:off x="9100000" y="0"/>
+            <a:ext cx="2406400" cy="502920"/>
+          </a:xfrm>
+          <a:prstGeom prst="rect">
+            <a:avLst/>
+          </a:prstGeom>
+          <a:noFill/>
+          <a:ln>
+            <a:noFill/>
+          </a:ln>
+        </p:spPr>
+        <p:txBody>
+          <a:bodyPr wrap="square" lIns="182880" tIns="91440" rIns="182880" bIns="91440" anchor="ctr">
+            <a:normAutofit/>
+          </a:bodyPr>
+          <a:lstStyle/>
+          <a:p>
+            <a:pPr algn="r"/>
+            <a:r>
+              <a:rPr lang="en-US" sz="1100" b="1" cap="all" spc="120">
+                <a:solidFill>
+                  <a:srgbClr val="BABEC3"/>
+                </a:solidFill>
+              </a:rPr>
+              <a:t>6 / 6</a:t>
+            </a:r>
+          </a:p>
+        </p:txBody>
+      </p:sp>
+      <p:sp>
+        <p:nvSpPr>
+          <p:cNvPr id="6" name="Title"/>
+          <p:cNvSpPr txBox="1"/>
+          <p:nvPr/>
+        </p:nvSpPr>
+        <p:spPr>
+          <a:xfrm>
+            <a:off x="685800" y="760000"/>
+            <a:ext cx="10820400" cy="1000000"/>
+          </a:xfrm>
+          <a:prstGeom prst="rect">
+            <a:avLst/>
+          </a:prstGeom>
+          <a:noFill/>
+          <a:ln>
+            <a:noFill/>
+          </a:ln>
+        </p:spPr>
+        <p:txBody>
+          <a:bodyPr wrap="square" lIns="182880" tIns="91440" rIns="182880" bIns="91440" anchor="ctr">
             <a:normAutofit/>
           </a:bodyPr>
           <a:lstStyle/>
@@ -2307,9 +2705,63 @@
               </a:spcAft>
             </a:pPr>
             <a:r>
+              <a:rPr lang="en-US" sz="2400" b="1">
+                <a:solidFill>
+                  <a:srgbClr val="081222"/>
+                </a:solidFill>
+                <a:latin typeface="+mj-lt"/>
+              </a:rPr>
+              <a:t>Sources.</a:t>
+            </a:r>
+            <a:r>
+              <a:rPr lang="en-US" sz="2400" b="1">
+                <a:solidFill>
+                  <a:srgbClr val="17796A"/>
+                </a:solidFill>
+                <a:latin typeface="+mj-lt"/>
+              </a:rPr>
+              <a:t> Every claim traces to one.</a:t>
+            </a:r>
+          </a:p>
+        </p:txBody>
+      </p:sp>
+      <p:sp>
+        <p:nvSpPr>
+          <p:cNvPr id="7" name="Sources"/>
+          <p:cNvSpPr txBox="1"/>
+          <p:nvPr/>
+        </p:nvSpPr>
+        <p:spPr>
+          <a:xfrm>
+            <a:off x="685800" y="1900000"/>
+            <a:ext cx="10820400" cy="4300000"/>
+          </a:xfrm>
+          <a:prstGeom prst="rect">
+            <a:avLst/>
+          </a:prstGeom>
+          <a:noFill/>
+          <a:ln>
+            <a:noFill/>
+          </a:ln>
+        </p:spPr>
+        <p:txBody>
+          <a:bodyPr wrap="square" lIns="182880" tIns="91440" rIns="182880" bIns="91440" anchor="t">
+            <a:normAutofit/>
+          </a:bodyPr>
+          <a:lstStyle/>
+          <a:p>
+            <a:pPr algn="l">
+              <a:lnSpc>
+                <a:spcPct val="105000"/>
+              </a:lnSpc>
+              <a:spcAft>
+                <a:spcPts val="0"/>
+              </a:spcAft>
+            </a:pPr>
+            <a:r>
               <a:rPr lang="en-US" sz="1400" b="1">
                 <a:solidFill>
-                  <a:srgbClr val="F2FBF8"/>
+                  <a:srgbClr val="081222"/>
                 </a:solidFill>
               </a:rPr>
               <a:t>Register now for PPCC 2026: Come for the learning, stay for the community</a:t>
@@ -2317,7 +2769,7 @@
             <a:r>
               <a:rPr lang="en-US" sz="1100">
                 <a:solidFill>
-                  <a:srgbClr val="B0BDBA"/>
+                  <a:srgbClr val="6B717A"/>
                 </a:solidFill>
               </a:rPr>
               <a:t>  retrieved 2026-10-05</a:t>
@@ -2335,7 +2787,7 @@
             <a:r>
               <a:rPr lang="en-US" sz="1100">
                 <a:solidFill>
-                  <a:srgbClr val="18A999"/>
+                  <a:srgbClr val="17796A"/>
                 </a:solidFill>
               </a:rPr>
               <a:t>https://www.microsoft.com/en-us/power-platform/blog/2026/08/13/register-now-for-ppcc-2026-come-for-the-learning-stay-for-the-community/</a:t>
@@ -2353,7 +2805,7 @@
             <a:r>
               <a:rPr lang="en-US" sz="1400" b="1">
                 <a:solidFill>
-                  <a:srgbClr val="F2FBF8"/>
+                  <a:srgbClr val="081222"/>
                 </a:solidFill>
               </a:rPr>
               <a:t>FAQ | PPCC26</a:t>
@@ -2361,7 +2813,7 @@
             <a:r>
               <a:rPr lang="en-US" sz="1100">
                 <a:solidFill>
-                  <a:srgbClr val="B0BDBA"/>
+                  <a:srgbClr val="6B717A"/>
                 </a:solidFill>
               </a:rPr>
               <a:t>  retrieved 2026-10-05</a:t>
@@ -2379,7 +2831,7 @@
             <a:r>
               <a:rPr lang="en-US" sz="1100">
                 <a:solidFill>
-                  <a:srgbClr val="18A999"/>
+                  <a:srgbClr val="17796A"/>
                 </a:solidFill>
               </a:rPr>
               <a:t>https://powerplatformconf.com/faq</a:t>
@@ -2389,14 +2841,14 @@
       </p:sp>
       <p:sp>
         <p:nvSpPr>
-          <p:cNvPr id="5" name="Footer"/>
+          <p:cNvPr id="8" name="Footer"/>
           <p:cNvSpPr txBox="1"/>
           <p:nvPr/>
         </p:nvSpPr>
         <p:spPr>
           <a:xfrm>
             <a:off x="685800" y="6250000"/>
-            <a:ext cx="9400000" cy="420000"/>
+            <a:ext cx="10820400" cy="420000"/>
           </a:xfrm>
           <a:prstGeom prst="rect">
             <a:avLst/>
@@ -2423,47 +2875,10 @@
             <a:r>
               <a:rPr lang="en-US" sz="1000">
                 <a:solidFill>
-                  <a:srgbClr val="B0BDBA"/>
-                </a:solidFill>
-              </a:rPr>
-              <a:t>power-platform-community-conference-2026-11-am-michael-kokoro-onnx</a:t>
-            </a:r>
-          </a:p>
-        </p:txBody>
-      </p:sp>
-      <p:sp>
-        <p:nvSpPr>
-          <p:cNvPr id="6" name="Slide number"/>
-          <p:cNvSpPr txBox="1"/>
-          <p:nvPr/>
-        </p:nvSpPr>
-        <p:spPr>
-          <a:xfrm>
-            <a:off x="10100000" y="6250000"/>
-            <a:ext cx="1400000" cy="420000"/>
-          </a:xfrm>
-          <a:prstGeom prst="rect">
-            <a:avLst/>
-          </a:prstGeom>
-          <a:noFill/>
-          <a:ln>
-            <a:noFill/>
-          </a:ln>
-        </p:spPr>
-        <p:txBody>
-          <a:bodyPr wrap="square" lIns="182880" tIns="91440" rIns="182880" bIns="91440" anchor="t">
-            <a:normAutofit/>
-          </a:bodyPr>
-          <a:lstStyle/>
-          <a:p>
-            <a:pPr algn="r"/>
-            <a:r>
-              <a:rPr lang="en-US" sz="1000">
-                <a:solidFill>
-                  <a:srgbClr val="B0BDBA"/>
-                </a:solidFill>
-              </a:rPr>
-              <a:t>6 / 6</a:t>
+                  <a:srgbClr val="6B717A"/>
+                </a:solidFill>
+              </a:rPr>
+              <a:t>power-platform-community-conference-2026-12-am-michael-kokoro-onnx</a:t>
             </a:r>
           </a:p>
         </p:txBody>
@@ -2477,59 +2892,59 @@
 </file>
 
 <file path=ppt/theme/theme1.xml><?xml version="1.0" encoding="utf-8"?>
-<a:theme xmlns:a="http://schemas.openxmlformats.org/drawingml/2006/main" name="executive-dark-green-teal">
+<a:theme xmlns:a="http://schemas.openxmlformats.org/drawingml/2006/main" name="power-platform-community-conference-brand">
   <a:themeElements>
-    <a:clrScheme name="executive-dark-green-teal">
+    <a:clrScheme name="power-platform-community-conference-brand">
       <a:dk1>
-        <a:srgbClr val="F2FBF8"/>
+        <a:srgbClr val="081222"/>
       </a:dk1>
       <a:lt1>
-        <a:srgbClr val="071F1B"/>
+        <a:srgbClr val="F5F9F8"/>
       </a:lt1>
       <a:dk2>
-        <a:srgbClr val="1F1F1F"/>
+        <a:srgbClr val="0A172A"/>
       </a:dk2>
       <a:lt2>
-        <a:srgbClr val="F8F8F8"/>
+        <a:srgbClr val="E8F2F0"/>
       </a:lt2>
       <a:accent1>
-        <a:srgbClr val="18A999"/>
+        <a:srgbClr val="17796A"/>
       </a:accent1>
       <a:accent2>
-        <a:srgbClr val="5B9BD5"/>
+        <a:srgbClr val="2FFFE0"/>
       </a:accent2>
       <a:accent3>
-        <a:srgbClr val="70AD47"/>
+        <a:srgbClr val="17796A"/>
       </a:accent3>
       <a:accent4>
-        <a:srgbClr val="FFC000"/>
+        <a:srgbClr val="070F1B"/>
       </a:accent4>
       <a:accent5>
-        <a:srgbClr val="C00000"/>
+        <a:srgbClr val="6B717A"/>
       </a:accent5>
       <a:accent6>
-        <a:srgbClr val="7030A0"/>
+        <a:srgbClr val="B42318"/>
       </a:accent6>
       <a:hlink>
-        <a:srgbClr val="18A999"/>
+        <a:srgbClr val="17796A"/>
       </a:hlink>
       <a:folHlink>
-        <a:srgbClr val="7F7F7F"/>
+        <a:srgbClr val="6B717A"/>
       </a:folHlink>
     </a:clrScheme>
-    <a:fontScheme name="executive-dark-green-teal">
+    <a:fontScheme name="power-platform-community-conference-brand">
       <a:majorFont>
-        <a:latin typeface="Arial"/>
+        <a:latin typeface="Montserrat"/>
         <a:ea typeface=""/>
         <a:cs typeface=""/>
       </a:majorFont>
       <a:minorFont>
-        <a:latin typeface="Arial"/>
+        <a:latin typeface="Montserrat"/>
         <a:ea typeface=""/>
         <a:cs typeface=""/>
       </a:minorFont>
     </a:fontScheme>
-    <a:fmtScheme name="executive-dark-green-teal">
+    <a:fmtScheme name="power-platform-community-conference-brand">
       <a:fillStyleLst>
         <a:solidFill>
           <a:schemeClr val="phClr"/>

</xml_diff>

<commit_message>
feat: regenerate power-platform-community-conference on media adapter 13
- render four voices with the current media adapter
- add video and spatial spectrograms and internal/external alignment evidence

🎨 - Generated by Copilot

Co-authored-by: Copilot <223556219+Copilot@users.noreply.github.com>
</commit_message>
<xml_diff>
--- a/projects/power-platform-community-conference/release/outputs/deck.pptx
+++ b/projects/power-platform-community-conference/release/outputs/deck.pptx
@@ -1127,7 +1127,7 @@
                   <a:srgbClr val="6B717A"/>
                 </a:solidFill>
               </a:rPr>
-              <a:t>power-platform-community-conference-2026-12-am-michael-kokoro-onnx</a:t>
+              <a:t>power-platform-community-conference-2026-13-am-michael-kokoro-onnx</a:t>
             </a:r>
           </a:p>
         </p:txBody>
@@ -2878,7 +2878,7 @@
                   <a:srgbClr val="6B717A"/>
                 </a:solidFill>
               </a:rPr>
-              <a:t>power-platform-community-conference-2026-12-am-michael-kokoro-onnx</a:t>
+              <a:t>power-platform-community-conference-2026-13-am-michael-kokoro-onnx</a:t>
             </a:r>
           </a:p>
         </p:txBody>

</xml_diff>